<commit_message>
Module 2: update slides 4 and 5 with the new results
Co-Authored-By: Claude Opus 5.5 <noreply@anthropic.com>
</commit_message>
<xml_diff>
--- a/presentation/presentation_slides.pptx
+++ b/presentation/presentation_slides.pptx
@@ -5079,7 +5079,7 @@
               </a:defRPr>
             </a:pPr>
             <a:r>
-              <a:t>Mathematical Analysis: Reproduction Number &amp; Equilibrium Stability</a:t>
+              <a:t>Mathematical Analysis: R0, Equilibria and Stability</a:t>
             </a:r>
           </a:p>
         </p:txBody>
@@ -5162,82 +5162,82 @@
               </a:defRPr>
             </a:pPr>
             <a:r>
-              <a:t>Next-Generation Matrix Derivation of R0</a:t>
-            </a:r>
-          </a:p>
-          <a:p>
-            <a:pPr>
-              <a:spcAft>
-                <a:spcPts val="400"/>
-              </a:spcAft>
-              <a:defRPr sz="1100">
-                <a:solidFill>
-                  <a:srgbClr val="1E293B"/>
-                </a:solidFill>
-              </a:defRPr>
-            </a:pPr>
-            <a:r>
-              <a:t>- Infected subsystem x = (e, i)^T.</a:t>
-            </a:r>
-          </a:p>
-          <a:p>
-            <a:pPr>
-              <a:spcAft>
-                <a:spcPts val="400"/>
-              </a:spcAft>
-              <a:defRPr sz="1100">
-                <a:solidFill>
-                  <a:srgbClr val="1E293B"/>
-                </a:solidFill>
-              </a:defRPr>
-            </a:pPr>
-            <a:r>
-              <a:t>- Transmission matrix F = [[0, beta], [0, 0]]; Transition matrix V = [[sigma, 0], [-sigma, gamma + mu]].</a:t>
-            </a:r>
-          </a:p>
-          <a:p>
-            <a:pPr>
-              <a:spcAft>
-                <a:spcPts val="400"/>
-              </a:spcAft>
-              <a:defRPr sz="1100">
-                <a:solidFill>
-                  <a:srgbClr val="1E293B"/>
-                </a:solidFill>
-              </a:defRPr>
-            </a:pPr>
-            <a:r>
-              <a:t>- Next-Generation Matrix FV^(-1) = [[beta/(gamma+mu), beta/(gamma+mu)], [0, 0]].</a:t>
-            </a:r>
-          </a:p>
-          <a:p>
-            <a:pPr>
-              <a:spcAft>
-                <a:spcPts val="400"/>
-              </a:spcAft>
-              <a:defRPr sz="1100">
-                <a:solidFill>
-                  <a:srgbClr val="1E293B"/>
-                </a:solidFill>
-              </a:defRPr>
-            </a:pPr>
-            <a:r>
-              <a:t>- Basic Reproduction Number: R0 = rho(FV^(-1)) = beta / (gamma + mu).</a:t>
-            </a:r>
-          </a:p>
-          <a:p>
-            <a:pPr>
-              <a:spcAft>
-                <a:spcPts val="400"/>
-              </a:spcAft>
-              <a:defRPr sz="1100">
-                <a:solidFill>
-                  <a:srgbClr val="1E293B"/>
-                </a:solidFill>
-              </a:defRPr>
-            </a:pPr>
-            <a:r>
-              <a:t>- Dynamic Effective Reproduction Number: Rt = beta(t) * s(t) / (gamma + mu).</a:t>
+              <a:t>R0 from the Next-Generation Matrix</a:t>
+            </a:r>
+          </a:p>
+          <a:p>
+            <a:pPr>
+              <a:spcAft>
+                <a:spcPts val="400"/>
+              </a:spcAft>
+              <a:defRPr sz="1100">
+                <a:solidFill>
+                  <a:srgbClr val="1E293B"/>
+                </a:solidFill>
+              </a:defRPr>
+            </a:pPr>
+            <a:r>
+              <a:t>- Infected classes x = (e, i). New infections F = [[0, βs*], [0, 0]]; moves between classes V = [[σ, 0], [−σ, γ+μ]].</a:t>
+            </a:r>
+          </a:p>
+          <a:p>
+            <a:pPr>
+              <a:spcAft>
+                <a:spcPts val="400"/>
+              </a:spcAft>
+              <a:defRPr sz="1100">
+                <a:solidFill>
+                  <a:srgbClr val="1E293B"/>
+                </a:solidFill>
+              </a:defRPr>
+            </a:pPr>
+            <a:r>
+              <a:t>- FV⁻¹ = [[βs*/(γ+μ), βs*/(γ+μ)], [0, 0]], so R0 = β/(γ+μ) = 0.4858 / 0.2429 ≈ 2.00 (at s* = 1).</a:t>
+            </a:r>
+          </a:p>
+          <a:p>
+            <a:pPr>
+              <a:spcAft>
+                <a:spcPts val="400"/>
+              </a:spcAft>
+              <a:defRPr sz="1100">
+                <a:solidFill>
+                  <a:srgbClr val="1E293B"/>
+                </a:solidFill>
+              </a:defRPr>
+            </a:pPr>
+            <a:r>
+              <a:t>- R0 does not contain σ: the incubation period delays new cases but does not change how many each case causes.</a:t>
+            </a:r>
+          </a:p>
+          <a:p>
+            <a:pPr>
+              <a:spcAft>
+                <a:spcPts val="400"/>
+              </a:spcAft>
+              <a:defRPr sz="1100">
+                <a:solidFill>
+                  <a:srgbClr val="1E293B"/>
+                </a:solidFill>
+              </a:defRPr>
+            </a:pPr>
+            <a:r>
+              <a:t>- Effective number Rt = β(t)·s(t)/(γ+μ). The outbreak shrinks once Rt &lt; 1.</a:t>
+            </a:r>
+          </a:p>
+          <a:p>
+            <a:pPr>
+              <a:spcAft>
+                <a:spcPts val="400"/>
+              </a:spcAft>
+              <a:defRPr sz="1100">
+                <a:solidFill>
+                  <a:srgbClr val="1E293B"/>
+                </a:solidFill>
+              </a:defRPr>
+            </a:pPr>
+            <a:r>
+              <a:t>- Meaning: early on, one infectious person infects about 2 others.</a:t>
             </a:r>
           </a:p>
         </p:txBody>
@@ -5320,67 +5320,67 @@
               </a:defRPr>
             </a:pPr>
             <a:r>
-              <a:t>Disease-Free Equilibrium (DFE) Stability</a:t>
-            </a:r>
-          </a:p>
-          <a:p>
-            <a:pPr>
-              <a:spcAft>
-                <a:spcPts val="400"/>
-              </a:spcAft>
-              <a:defRPr sz="1100">
-                <a:solidFill>
-                  <a:srgbClr val="1E293B"/>
-                </a:solidFill>
-              </a:defRPr>
-            </a:pPr>
-            <a:r>
-              <a:t>- Equilibrium states: y*_DFE = (s*, 0, 0, r*, d*) with s* + r* + d* = 1.</a:t>
-            </a:r>
-          </a:p>
-          <a:p>
-            <a:pPr>
-              <a:spcAft>
-                <a:spcPts val="400"/>
-              </a:spcAft>
-              <a:defRPr sz="1100">
-                <a:solidFill>
-                  <a:srgbClr val="1E293B"/>
-                </a:solidFill>
-              </a:defRPr>
-            </a:pPr>
-            <a:r>
-              <a:t>- Jacobian characteristic equation yields three neutral eigenvalues (lambda = 0) and quadratic factor: lambda^2 + (sigma + gamma + mu)lambda + sigma(gamma + mu)(1 - R0*s*) = 0.</a:t>
-            </a:r>
-          </a:p>
-          <a:p>
-            <a:pPr>
-              <a:spcAft>
-                <a:spcPts val="400"/>
-              </a:spcAft>
-              <a:defRPr sz="1100">
-                <a:solidFill>
-                  <a:srgbClr val="1E293B"/>
-                </a:solidFill>
-              </a:defRPr>
-            </a:pPr>
-            <a:r>
-              <a:t>- Routh-Hurwitz Stability Criterion: DFE is locally asymptotically stable iff 1 - R0*s* &gt; 0 =&gt; R0*s* &lt; 1.</a:t>
-            </a:r>
-          </a:p>
-          <a:p>
-            <a:pPr>
-              <a:spcAft>
-                <a:spcPts val="400"/>
-              </a:spcAft>
-              <a:defRPr sz="1100">
-                <a:solidFill>
-                  <a:srgbClr val="1E293B"/>
-                </a:solidFill>
-              </a:defRPr>
-            </a:pPr>
-            <a:r>
-              <a:t>- If R0*s* &gt; 1, the disease-free state is unstable and an epidemic outbreak occurs.</a:t>
+              <a:t>Disease-Free Equilibria and Their Stability</a:t>
+            </a:r>
+          </a:p>
+          <a:p>
+            <a:pPr>
+              <a:spcAft>
+                <a:spcPts val="400"/>
+              </a:spcAft>
+              <a:defRPr sz="1100">
+                <a:solidFill>
+                  <a:srgbClr val="1E293B"/>
+                </a:solidFill>
+              </a:defRPr>
+            </a:pPr>
+            <a:r>
+              <a:t>- Every equilibrium is disease-free, (s*, 0, 0, r*, d*). No births and lasting immunity, so every epidemic burns out.</a:t>
+            </a:r>
+          </a:p>
+          <a:p>
+            <a:pPr>
+              <a:spcAft>
+                <a:spcPts val="400"/>
+              </a:spcAft>
+              <a:defRPr sz="1100">
+                <a:solidFill>
+                  <a:srgbClr val="1E293B"/>
+                </a:solidFill>
+              </a:defRPr>
+            </a:pPr>
+            <a:r>
+              <a:t>- Jacobian: three zero eigenvalues (sliding along the family of equilibria) and two roots of λ² + (σ+γ+μ)λ + σ(γ+μ)(1 − R0·s*) = 0.</a:t>
+            </a:r>
+          </a:p>
+          <a:p>
+            <a:pPr>
+              <a:spcAft>
+                <a:spcPts val="400"/>
+              </a:spcAft>
+              <a:defRPr sz="1100">
+                <a:solidFill>
+                  <a:srgbClr val="1E293B"/>
+                </a:solidFill>
+              </a:defRPr>
+            </a:pPr>
+            <a:r>
+              <a:t>- R0·s* &lt; 1: both roots negative, a few new cases die out (stable, though not asymptotically, because of the zero eigenvalues). R0·s* &gt; 1: one root positive, an outbreak grows.</a:t>
+            </a:r>
+          </a:p>
+          <a:p>
+            <a:pPr>
+              <a:spcAft>
+                <a:spcPts val="400"/>
+              </a:spcAft>
+              <a:defRPr sz="1100">
+                <a:solidFill>
+                  <a:srgbClr val="1E293B"/>
+                </a:solidFill>
+              </a:defRPr>
+            </a:pPr>
+            <a:r>
+              <a:t>- The positive root is the early growth rate: 0.0627 per day (doubling in about 11 days). A simulation matches it to 0.003%.</a:t>
             </a:r>
           </a:p>
         </p:txBody>
@@ -5445,7 +5445,7 @@
               </a:defRPr>
             </a:pPr>
             <a:r>
-              <a:t>Theoretical Final-Size Relation &amp; Global Sensitivity</a:t>
+              <a:t>Final-Size Relation and Sensitivity Analysis</a:t>
             </a:r>
           </a:p>
         </p:txBody>
@@ -5528,52 +5528,52 @@
               </a:defRPr>
             </a:pPr>
             <a:r>
-              <a:t>Transcendental Final-Size Equation</a:t>
-            </a:r>
-          </a:p>
-          <a:p>
-            <a:pPr>
-              <a:spcAft>
-                <a:spcPts val="400"/>
-              </a:spcAft>
-              <a:defRPr sz="1100">
-                <a:solidFill>
-                  <a:srgbClr val="1E293B"/>
-                </a:solidFill>
-              </a:defRPr>
-            </a:pPr>
-            <a:r>
-              <a:t>- Dividing ds/d(r+d) = -R0 * s and integrating yields: ln(s0 / s_inf) = R0 * (1 - s_inf).</a:t>
-            </a:r>
-          </a:p>
-          <a:p>
-            <a:pPr>
-              <a:spcAft>
-                <a:spcPts val="400"/>
-              </a:spcAft>
-              <a:defRPr sz="1100">
-                <a:solidFill>
-                  <a:srgbClr val="1E293B"/>
-                </a:solidFill>
-              </a:defRPr>
-            </a:pPr>
-            <a:r>
-              <a:t>- Validated across multiple R0 values against high-precision numerical ODE simulations (DOP853).</a:t>
-            </a:r>
-          </a:p>
-          <a:p>
-            <a:pPr>
-              <a:spcAft>
-                <a:spcPts val="400"/>
-              </a:spcAft>
-              <a:defRPr sz="1100">
-                <a:solidFill>
-                  <a:srgbClr val="1E293B"/>
-                </a:solidFill>
-              </a:defRPr>
-            </a:pPr>
-            <a:r>
-              <a:t>- Relative error drops from 5.56e-2 at R0=1.5 to 9.22e-6 at R0=3.5, confirming analytical exactness.</a:t>
+              <a:t>Final-Size Relation (constant β)</a:t>
+            </a:r>
+          </a:p>
+          <a:p>
+            <a:pPr>
+              <a:spcAft>
+                <a:spcPts val="400"/>
+              </a:spcAft>
+              <a:defRPr sz="1100">
+                <a:solidFill>
+                  <a:srgbClr val="1E293B"/>
+                </a:solidFill>
+              </a:defRPr>
+            </a:pPr>
+            <a:r>
+              <a:t>- From ds/d(r+d) = −R0·s: ln(s0/s∞) = R0(1 − s∞ − r0 − d0), and final deaths d∞ = d0 + μ/(γ+μ)·(1 − s∞ − r0 − d0).</a:t>
+            </a:r>
+          </a:p>
+          <a:p>
+            <a:pPr>
+              <a:spcAft>
+                <a:spcPts val="400"/>
+              </a:spcAft>
+              <a:defRPr sz="1100">
+                <a:solidFill>
+                  <a:srgbClr val="1E293B"/>
+                </a:solidFill>
+              </a:defRPr>
+            </a:pPr>
+            <a:r>
+              <a:t>- At R0 = 2: about 80% are infected by the end (s∞ = 0.1998) and 33% die (d∞ = 0.3295).</a:t>
+            </a:r>
+          </a:p>
+          <a:p>
+            <a:pPr>
+              <a:spcAft>
+                <a:spcPts val="400"/>
+              </a:spcAft>
+              <a:defRPr sz="1100">
+                <a:solidFill>
+                  <a:srgbClr val="1E293B"/>
+                </a:solidFill>
+              </a:defRPr>
+            </a:pPr>
+            <a:r>
+              <a:t>- Formula and ODE agree to about 10⁻¹² for R0 from 0.8 to 3.5, once the ODE runs until the epidemic is over (e+i &lt; 10⁻¹³). Stopping at day 250 left errors up to 0.6%.</a:t>
             </a:r>
           </a:p>
         </p:txBody>
@@ -5656,67 +5656,67 @@
               </a:defRPr>
             </a:pPr>
             <a:r>
-              <a:t>Global Sensitivity Analysis (LHS-PRCC)</a:t>
-            </a:r>
-          </a:p>
-          <a:p>
-            <a:pPr>
-              <a:spcAft>
-                <a:spcPts val="400"/>
-              </a:spcAft>
-              <a:defRPr sz="1100">
-                <a:solidFill>
-                  <a:srgbClr val="1E293B"/>
-                </a:solidFill>
-              </a:defRPr>
-            </a:pPr>
-            <a:r>
-              <a:t>- Normalized analytical index: Sensitivity of R0 to beta is +1.0, to gamma is -0.952.</a:t>
-            </a:r>
-          </a:p>
-          <a:p>
-            <a:pPr>
-              <a:spcAft>
-                <a:spcPts val="400"/>
-              </a:spcAft>
-              <a:defRPr sz="1100">
-                <a:solidFill>
-                  <a:srgbClr val="1E293B"/>
-                </a:solidFill>
-              </a:defRPr>
-            </a:pPr>
-            <a:r>
-              <a:t>- Latin Hypercube Sampling (N=400) + Partial Rank Correlation Coefficients (PRCC) on nonlinear dynamics.</a:t>
-            </a:r>
-          </a:p>
-          <a:p>
-            <a:pPr>
-              <a:spcAft>
-                <a:spcPts val="400"/>
-              </a:spcAft>
-              <a:defRPr sz="1100">
-                <a:solidFill>
-                  <a:srgbClr val="1E293B"/>
-                </a:solidFill>
-              </a:defRPr>
-            </a:pPr>
-            <a:r>
-              <a:t>- Transmission beta exhibits dominant positive correlation with peak infection and final attack rate.</a:t>
-            </a:r>
-          </a:p>
-          <a:p>
-            <a:pPr>
-              <a:spcAft>
-                <a:spcPts val="400"/>
-              </a:spcAft>
-              <a:defRPr sz="1100">
-                <a:solidFill>
-                  <a:srgbClr val="1E293B"/>
-                </a:solidFill>
-              </a:defRPr>
-            </a:pPr>
-            <a:r>
-              <a:t>- Recovery gamma acts as the primary suppressing factor, while incubation sigma impacts peak timing.</a:t>
+              <a:t>Global Sensitivity (Latin Hypercube + PRCC, n = 1000)</a:t>
+            </a:r>
+          </a:p>
+          <a:p>
+            <a:pPr>
+              <a:spcAft>
+                <a:spcPts val="400"/>
+              </a:spcAft>
+              <a:defRPr sz="1100">
+                <a:solidFill>
+                  <a:srgbClr val="1E293B"/>
+                </a:solidFill>
+              </a:defRPr>
+            </a:pPr>
+            <a:r>
+              <a:t>- Local indices of R0: β +1, γ −0.59, μ −0.41, σ 0. A 10% cut in transmission lowers R0 by 10%.</a:t>
+            </a:r>
+          </a:p>
+          <a:p>
+            <a:pPr>
+              <a:spcAft>
+                <a:spcPts val="400"/>
+              </a:spcAft>
+              <a:defRPr sz="1100">
+                <a:solidFill>
+                  <a:srgbClr val="1E293B"/>
+                </a:solidFill>
+              </a:defRPr>
+            </a:pPr>
+            <a:r>
+              <a:t>- β pushes every output up (PRCC +0.90 to +0.98). γ and μ shrink the epidemic, but μ still raises total deaths (+0.75).</a:t>
+            </a:r>
+          </a:p>
+          <a:p>
+            <a:pPr>
+              <a:spcAft>
+                <a:spcPts val="400"/>
+              </a:spcAft>
+              <a:defRPr sz="1100">
+                <a:solidFill>
+                  <a:srgbClr val="1E293B"/>
+                </a:solidFill>
+              </a:defRPr>
+            </a:pPr>
+            <a:r>
+              <a:t>- σ moves the peak (height +0.68, timing −0.83) but not the final size (PRCC ≈ 0), as the formula predicts.</a:t>
+            </a:r>
+          </a:p>
+          <a:p>
+            <a:pPr>
+              <a:spcAft>
+                <a:spcPts val="400"/>
+              </a:spcAft>
+              <a:defRPr sz="1100">
+                <a:solidFill>
+                  <a:srgbClr val="1E293B"/>
+                </a:solidFill>
+              </a:defRPr>
+            </a:pPr>
+            <a:r>
+              <a:t>- With β(t) changing in time there is no closed formula, and cases plus deaths cannot separate σ, γ, μ. So we fix σ, γ and let the PINN learn β(t).</a:t>
             </a:r>
           </a:p>
         </p:txBody>

</xml_diff>

<commit_message>
Module 2: redesign slides 4 and 5 so they are easy to read
Same header, boxes and colours as the rest of the deck. Each box now
has one big formula, short 15-16 pt points, and a real table: the
eigenvalues with stable/unstable marked, and the PRCC values with
non-significant ones greyed. Slide 5 shows the final size as two big
numbers (80% infected, 33% die). Other slides are unchanged.

Co-Authored-By: Claude Opus 5.5 <noreply@anthropic.com>
</commit_message>
<xml_diff>
--- a/presentation/presentation_slides.pptx
+++ b/presentation/presentation_slides.pptx
@@ -5079,7 +5079,31 @@
               </a:defRPr>
             </a:pPr>
             <a:r>
-              <a:t>Mathematical Analysis: R0, Equilibria and Stability</a:t>
+              <a:rPr lang="en-GB" sz="2200" b="1" dirty="0">
+                <a:solidFill>
+                  <a:srgbClr val="0F2240"/>
+                </a:solidFill>
+                <a:latin typeface="+mn-lt"/>
+              </a:rPr>
+              <a:t>Mathematical Analysis: R</a:t>
+            </a:r>
+            <a:r>
+              <a:rPr lang="en-GB" sz="2200" b="1" baseline="-25000" dirty="0">
+                <a:solidFill>
+                  <a:srgbClr val="0F2240"/>
+                </a:solidFill>
+                <a:latin typeface="+mn-lt"/>
+              </a:rPr>
+              <a:t>0</a:t>
+            </a:r>
+            <a:r>
+              <a:rPr lang="en-GB" sz="2200" b="1" dirty="0">
+                <a:solidFill>
+                  <a:srgbClr val="0F2240"/>
+                </a:solidFill>
+                <a:latin typeface="+mn-lt"/>
+              </a:rPr>
+              <a:t>, Equilibria and Stability</a:t>
             </a:r>
           </a:p>
         </p:txBody>
@@ -5131,119 +5155,6 @@
       </p:sp>
       <p:sp>
         <p:nvSpPr>
-          <p:cNvPr id="4" name="TextBox 3"/>
-          <p:cNvSpPr txBox="1"/>
-          <p:nvPr/>
-        </p:nvSpPr>
-        <p:spPr>
-          <a:xfrm>
-            <a:off x="960120" y="1828800"/>
-            <a:ext cx="4663440" cy="4206240"/>
-          </a:xfrm>
-          <a:prstGeom prst="rect">
-            <a:avLst/>
-          </a:prstGeom>
-          <a:noFill/>
-        </p:spPr>
-        <p:txBody>
-          <a:bodyPr wrap="square" tIns="0" bIns="0" lIns="0" rIns="0">
-            <a:spAutoFit/>
-          </a:bodyPr>
-          <a:lstStyle/>
-          <a:p>
-            <a:pPr>
-              <a:spcAft>
-                <a:spcPts val="800"/>
-              </a:spcAft>
-              <a:defRPr sz="1500" b="1">
-                <a:solidFill>
-                  <a:srgbClr val="0F2240"/>
-                </a:solidFill>
-              </a:defRPr>
-            </a:pPr>
-            <a:r>
-              <a:t>R0 from the Next-Generation Matrix</a:t>
-            </a:r>
-          </a:p>
-          <a:p>
-            <a:pPr>
-              <a:spcAft>
-                <a:spcPts val="400"/>
-              </a:spcAft>
-              <a:defRPr sz="1100">
-                <a:solidFill>
-                  <a:srgbClr val="1E293B"/>
-                </a:solidFill>
-              </a:defRPr>
-            </a:pPr>
-            <a:r>
-              <a:t>- Infected classes x = (e, i). New infections F = [[0, βs*], [0, 0]]; moves between classes V = [[σ, 0], [−σ, γ+μ]].</a:t>
-            </a:r>
-          </a:p>
-          <a:p>
-            <a:pPr>
-              <a:spcAft>
-                <a:spcPts val="400"/>
-              </a:spcAft>
-              <a:defRPr sz="1100">
-                <a:solidFill>
-                  <a:srgbClr val="1E293B"/>
-                </a:solidFill>
-              </a:defRPr>
-            </a:pPr>
-            <a:r>
-              <a:t>- FV⁻¹ = [[βs*/(γ+μ), βs*/(γ+μ)], [0, 0]], so R0 = β/(γ+μ) = 0.4858 / 0.2429 ≈ 2.00 (at s* = 1).</a:t>
-            </a:r>
-          </a:p>
-          <a:p>
-            <a:pPr>
-              <a:spcAft>
-                <a:spcPts val="400"/>
-              </a:spcAft>
-              <a:defRPr sz="1100">
-                <a:solidFill>
-                  <a:srgbClr val="1E293B"/>
-                </a:solidFill>
-              </a:defRPr>
-            </a:pPr>
-            <a:r>
-              <a:t>- R0 does not contain σ: the incubation period delays new cases but does not change how many each case causes.</a:t>
-            </a:r>
-          </a:p>
-          <a:p>
-            <a:pPr>
-              <a:spcAft>
-                <a:spcPts val="400"/>
-              </a:spcAft>
-              <a:defRPr sz="1100">
-                <a:solidFill>
-                  <a:srgbClr val="1E293B"/>
-                </a:solidFill>
-              </a:defRPr>
-            </a:pPr>
-            <a:r>
-              <a:t>- Effective number Rt = β(t)·s(t)/(γ+μ). The outbreak shrinks once Rt &lt; 1.</a:t>
-            </a:r>
-          </a:p>
-          <a:p>
-            <a:pPr>
-              <a:spcAft>
-                <a:spcPts val="400"/>
-              </a:spcAft>
-              <a:defRPr sz="1100">
-                <a:solidFill>
-                  <a:srgbClr val="1E293B"/>
-                </a:solidFill>
-              </a:defRPr>
-            </a:pPr>
-            <a:r>
-              <a:t>- Meaning: early on, one infectious person infects about 2 others.</a:t>
-            </a:r>
-          </a:p>
-        </p:txBody>
-      </p:sp>
-      <p:sp>
-        <p:nvSpPr>
           <p:cNvPr id="5" name="Rounded Rectangle 4"/>
           <p:cNvSpPr/>
           <p:nvPr/>
@@ -5289,14 +5200,14 @@
       </p:sp>
       <p:sp>
         <p:nvSpPr>
-          <p:cNvPr id="6" name="TextBox 5"/>
+          <p:cNvPr id="101" name="Heading"/>
           <p:cNvSpPr txBox="1"/>
           <p:nvPr/>
         </p:nvSpPr>
         <p:spPr>
           <a:xfrm>
-            <a:off x="6446520" y="1828800"/>
-            <a:ext cx="4754880" cy="4206240"/>
+            <a:off x="960120" y="1828800"/>
+            <a:ext cx="4663440" cy="420000"/>
           </a:xfrm>
           <a:prstGeom prst="rect">
             <a:avLst/>
@@ -5304,83 +5215,1204 @@
           <a:noFill/>
         </p:spPr>
         <p:txBody>
-          <a:bodyPr wrap="square" tIns="0" bIns="0" lIns="0" rIns="0">
-            <a:spAutoFit/>
+          <a:bodyPr wrap="square" lIns="0" tIns="0" rIns="0" bIns="0" anchor="t">
+            <a:noAutofit/>
           </a:bodyPr>
           <a:lstStyle/>
           <a:p>
-            <a:pPr>
+            <a:pPr algn="l">
+              <a:buNone/>
+            </a:pPr>
+            <a:r>
+              <a:rPr lang="en-GB" sz="2000" b="1" dirty="0">
+                <a:solidFill>
+                  <a:srgbClr val="0F2240"/>
+                </a:solidFill>
+                <a:latin typeface="+mn-lt"/>
+              </a:rPr>
+              <a:t>R</a:t>
+            </a:r>
+            <a:r>
+              <a:rPr lang="en-GB" sz="2000" b="1" baseline="-25000" dirty="0">
+                <a:solidFill>
+                  <a:srgbClr val="0F2240"/>
+                </a:solidFill>
+                <a:latin typeface="+mn-lt"/>
+              </a:rPr>
+              <a:t>0</a:t>
+            </a:r>
+            <a:r>
+              <a:rPr lang="en-GB" sz="2000" b="1" dirty="0">
+                <a:solidFill>
+                  <a:srgbClr val="0F2240"/>
+                </a:solidFill>
+                <a:latin typeface="+mn-lt"/>
+              </a:rPr>
+              <a:t xml:space="preserve"> from the next-generation matrix</a:t>
+            </a:r>
+          </a:p>
+        </p:txBody>
+      </p:sp>
+      <p:sp>
+        <p:nvSpPr>
+          <p:cNvPr id="102" name="R0 callout"/>
+          <p:cNvSpPr/>
+          <p:nvPr/>
+        </p:nvSpPr>
+        <p:spPr>
+          <a:xfrm>
+            <a:off x="960120" y="2330000"/>
+            <a:ext cx="4663440" cy="950000"/>
+          </a:xfrm>
+          <a:prstGeom prst="roundRect">
+            <a:avLst>
+              <a:gd name="adj" fmla="val 12000"/>
+            </a:avLst>
+          </a:prstGeom>
+          <a:solidFill>
+            <a:srgbClr val="EEF4FB"/>
+          </a:solidFill>
+          <a:ln>
+            <a:noFill/>
+          </a:ln>
+        </p:spPr>
+        <p:txBody>
+          <a:bodyPr wrap="square" lIns="91440" tIns="45720" rIns="91440" bIns="45720" anchor="ctr">
+            <a:normAutofit/>
+          </a:bodyPr>
+          <a:lstStyle/>
+          <a:p>
+            <a:pPr algn="ctr">
+              <a:buNone/>
+            </a:pPr>
+            <a:r>
+              <a:rPr lang="en-GB" sz="3400" b="1" dirty="0">
+                <a:solidFill>
+                  <a:srgbClr val="0F2240"/>
+                </a:solidFill>
+                <a:latin typeface="+mn-lt"/>
+              </a:rPr>
+              <a:t>R</a:t>
+            </a:r>
+            <a:r>
+              <a:rPr lang="en-GB" sz="3400" b="1" baseline="-25000" dirty="0">
+                <a:solidFill>
+                  <a:srgbClr val="0F2240"/>
+                </a:solidFill>
+                <a:latin typeface="+mn-lt"/>
+              </a:rPr>
+              <a:t>0</a:t>
+            </a:r>
+            <a:r>
+              <a:rPr lang="en-GB" sz="3400" b="1" dirty="0">
+                <a:solidFill>
+                  <a:srgbClr val="0F2240"/>
+                </a:solidFill>
+                <a:latin typeface="+mn-lt"/>
+              </a:rPr>
+              <a:t xml:space="preserve"> = β / (γ + μ) ≈ 2.0</a:t>
+            </a:r>
+          </a:p>
+        </p:txBody>
+      </p:sp>
+      <p:sp>
+        <p:nvSpPr>
+          <p:cNvPr id="103" name="R0 points"/>
+          <p:cNvSpPr txBox="1"/>
+          <p:nvPr/>
+        </p:nvSpPr>
+        <p:spPr>
+          <a:xfrm>
+            <a:off x="960120" y="3480000"/>
+            <a:ext cx="4663440" cy="2550000"/>
+          </a:xfrm>
+          <a:prstGeom prst="rect">
+            <a:avLst/>
+          </a:prstGeom>
+          <a:noFill/>
+        </p:spPr>
+        <p:txBody>
+          <a:bodyPr wrap="square" lIns="0" tIns="0" rIns="0" bIns="0" anchor="t">
+            <a:noAutofit/>
+          </a:bodyPr>
+          <a:lstStyle/>
+          <a:p>
+            <a:pPr algn="l" marL="228600" indent="-228600">
               <a:spcAft>
-                <a:spcPts val="800"/>
+                <a:spcPts val="1000"/>
               </a:spcAft>
-              <a:defRPr sz="1500" b="1">
+              <a:buClr>
+                <a:srgbClr val="1A56A0"/>
+              </a:buClr>
+              <a:buFont typeface="Arial"/>
+              <a:buChar char="•"/>
+            </a:pPr>
+            <a:r>
+              <a:rPr lang="en-GB" sz="1600" b="0" dirty="0">
+                <a:solidFill>
+                  <a:srgbClr val="1E293B"/>
+                </a:solidFill>
+                <a:latin typeface="+mn-lt"/>
+              </a:rPr>
+              <a:t>Split the (e, i) equations into new infections F and moves between classes V. R</a:t>
+            </a:r>
+            <a:r>
+              <a:rPr lang="en-GB" sz="1600" b="0" baseline="-25000" dirty="0">
+                <a:solidFill>
+                  <a:srgbClr val="1E293B"/>
+                </a:solidFill>
+                <a:latin typeface="+mn-lt"/>
+              </a:rPr>
+              <a:t>0</a:t>
+            </a:r>
+            <a:r>
+              <a:rPr lang="en-GB" sz="1600" b="0" dirty="0">
+                <a:solidFill>
+                  <a:srgbClr val="1E293B"/>
+                </a:solidFill>
+                <a:latin typeface="+mn-lt"/>
+              </a:rPr>
+              <a:t xml:space="preserve"> is the largest eigenvalue of FV</a:t>
+            </a:r>
+            <a:r>
+              <a:rPr lang="en-GB" sz="1600" b="0" baseline="30000" dirty="0">
+                <a:solidFill>
+                  <a:srgbClr val="1E293B"/>
+                </a:solidFill>
+                <a:latin typeface="+mn-lt"/>
+              </a:rPr>
+              <a:t>−1</a:t>
+            </a:r>
+            <a:r>
+              <a:rPr lang="en-GB" sz="1600" b="0" dirty="0">
+                <a:solidFill>
+                  <a:srgbClr val="1E293B"/>
+                </a:solidFill>
+                <a:latin typeface="+mn-lt"/>
+              </a:rPr>
+              <a:t>.</a:t>
+            </a:r>
+          </a:p>
+          <a:p>
+            <a:pPr algn="l" marL="228600" indent="-228600">
+              <a:spcAft>
+                <a:spcPts val="1000"/>
+              </a:spcAft>
+              <a:buClr>
+                <a:srgbClr val="1A56A0"/>
+              </a:buClr>
+              <a:buFont typeface="Arial"/>
+              <a:buChar char="•"/>
+            </a:pPr>
+            <a:r>
+              <a:rPr lang="en-GB" sz="1600" b="0" dirty="0">
+                <a:solidFill>
+                  <a:srgbClr val="1E293B"/>
+                </a:solidFill>
+                <a:latin typeface="+mn-lt"/>
+              </a:rPr>
+              <a:t>Rate × time: 0.486 per day × 4.1 infectious days ≈ 2.</a:t>
+            </a:r>
+          </a:p>
+          <a:p>
+            <a:pPr algn="l" marL="228600" indent="-228600">
+              <a:spcAft>
+                <a:spcPts val="1000"/>
+              </a:spcAft>
+              <a:buClr>
+                <a:srgbClr val="1A56A0"/>
+              </a:buClr>
+              <a:buFont typeface="Arial"/>
+              <a:buChar char="•"/>
+            </a:pPr>
+            <a:r>
+              <a:rPr lang="en-GB" sz="1600" b="0" dirty="0">
+                <a:solidFill>
+                  <a:srgbClr val="1E293B"/>
+                </a:solidFill>
+                <a:latin typeface="+mn-lt"/>
+              </a:rPr>
+              <a:t>σ drops out: incubation changes when people infect others, not how many.</a:t>
+            </a:r>
+          </a:p>
+          <a:p>
+            <a:pPr algn="l" marL="228600" indent="-228600">
+              <a:buClr>
+                <a:srgbClr val="1A56A0"/>
+              </a:buClr>
+              <a:buFont typeface="Arial"/>
+              <a:buChar char="•"/>
+            </a:pPr>
+            <a:r>
+              <a:rPr lang="en-GB" sz="1600" b="0" dirty="0">
+                <a:solidFill>
+                  <a:srgbClr val="1E293B"/>
+                </a:solidFill>
+                <a:latin typeface="+mn-lt"/>
+              </a:rPr>
+              <a:t>Over time, R</a:t>
+            </a:r>
+            <a:r>
+              <a:rPr lang="en-GB" sz="1600" b="0" baseline="-25000" dirty="0">
+                <a:solidFill>
+                  <a:srgbClr val="1E293B"/>
+                </a:solidFill>
+                <a:latin typeface="+mn-lt"/>
+              </a:rPr>
+              <a:t>t</a:t>
+            </a:r>
+            <a:r>
+              <a:rPr lang="en-GB" sz="1600" b="0" dirty="0">
+                <a:solidFill>
+                  <a:srgbClr val="1E293B"/>
+                </a:solidFill>
+                <a:latin typeface="+mn-lt"/>
+              </a:rPr>
+              <a:t xml:space="preserve"> = β(t) s(t) / (γ + μ); cases fall once R</a:t>
+            </a:r>
+            <a:r>
+              <a:rPr lang="en-GB" sz="1600" b="0" baseline="-25000" dirty="0">
+                <a:solidFill>
+                  <a:srgbClr val="1E293B"/>
+                </a:solidFill>
+                <a:latin typeface="+mn-lt"/>
+              </a:rPr>
+              <a:t>t</a:t>
+            </a:r>
+            <a:r>
+              <a:rPr lang="en-GB" sz="1600" b="0" dirty="0">
+                <a:solidFill>
+                  <a:srgbClr val="1E293B"/>
+                </a:solidFill>
+                <a:latin typeface="+mn-lt"/>
+              </a:rPr>
+              <a:t xml:space="preserve"> &lt; 1.</a:t>
+            </a:r>
+          </a:p>
+        </p:txBody>
+      </p:sp>
+      <p:sp>
+        <p:nvSpPr>
+          <p:cNvPr id="104" name="Heading"/>
+          <p:cNvSpPr txBox="1"/>
+          <p:nvPr/>
+        </p:nvSpPr>
+        <p:spPr>
+          <a:xfrm>
+            <a:off x="6446520" y="1828800"/>
+            <a:ext cx="4754880" cy="420000"/>
+          </a:xfrm>
+          <a:prstGeom prst="rect">
+            <a:avLst/>
+          </a:prstGeom>
+          <a:noFill/>
+        </p:spPr>
+        <p:txBody>
+          <a:bodyPr wrap="square" lIns="0" tIns="0" rIns="0" bIns="0" anchor="t">
+            <a:noAutofit/>
+          </a:bodyPr>
+          <a:lstStyle/>
+          <a:p>
+            <a:pPr algn="l">
+              <a:buNone/>
+            </a:pPr>
+            <a:r>
+              <a:rPr lang="en-GB" sz="2000" b="1" dirty="0">
                 <a:solidFill>
                   <a:srgbClr val="0F2240"/>
                 </a:solidFill>
-              </a:defRPr>
-            </a:pPr>
-            <a:r>
-              <a:t>Disease-Free Equilibria and Their Stability</a:t>
-            </a:r>
-          </a:p>
-          <a:p>
-            <a:pPr>
+                <a:latin typeface="+mn-lt"/>
+              </a:rPr>
+              <a:t>Equilibria and their stability</a:t>
+            </a:r>
+          </a:p>
+        </p:txBody>
+      </p:sp>
+      <p:sp>
+        <p:nvSpPr>
+          <p:cNvPr id="105" name="Equilibria line"/>
+          <p:cNvSpPr txBox="1"/>
+          <p:nvPr/>
+        </p:nvSpPr>
+        <p:spPr>
+          <a:xfrm>
+            <a:off x="6446520" y="2330000"/>
+            <a:ext cx="4754880" cy="330000"/>
+          </a:xfrm>
+          <a:prstGeom prst="rect">
+            <a:avLst/>
+          </a:prstGeom>
+          <a:noFill/>
+        </p:spPr>
+        <p:txBody>
+          <a:bodyPr wrap="square" lIns="0" tIns="0" rIns="0" bIns="0" anchor="t">
+            <a:noAutofit/>
+          </a:bodyPr>
+          <a:lstStyle/>
+          <a:p>
+            <a:pPr algn="l">
+              <a:buNone/>
+            </a:pPr>
+            <a:r>
+              <a:rPr lang="en-GB" sz="1600" b="0" dirty="0">
+                <a:solidFill>
+                  <a:srgbClr val="1E293B"/>
+                </a:solidFill>
+                <a:latin typeface="+mn-lt"/>
+              </a:rPr>
+              <a:t>Every equilibrium is disease-free: (s*, 0, 0, r*, d*).</a:t>
+            </a:r>
+          </a:p>
+        </p:txBody>
+      </p:sp>
+      <p:sp>
+        <p:nvSpPr>
+          <p:cNvPr id="106" name="Threshold callout"/>
+          <p:cNvSpPr/>
+          <p:nvPr/>
+        </p:nvSpPr>
+        <p:spPr>
+          <a:xfrm>
+            <a:off x="6446520" y="2740000"/>
+            <a:ext cx="4754880" cy="700000"/>
+          </a:xfrm>
+          <a:prstGeom prst="roundRect">
+            <a:avLst>
+              <a:gd name="adj" fmla="val 12000"/>
+            </a:avLst>
+          </a:prstGeom>
+          <a:solidFill>
+            <a:srgbClr val="EEF4FB"/>
+          </a:solidFill>
+          <a:ln>
+            <a:noFill/>
+          </a:ln>
+        </p:spPr>
+        <p:txBody>
+          <a:bodyPr wrap="square" lIns="91440" tIns="45720" rIns="91440" bIns="45720" anchor="ctr">
+            <a:normAutofit/>
+          </a:bodyPr>
+          <a:lstStyle/>
+          <a:p>
+            <a:pPr algn="ctr">
+              <a:buNone/>
+            </a:pPr>
+            <a:r>
+              <a:rPr lang="en-GB" sz="2600" b="1" dirty="0">
+                <a:solidFill>
+                  <a:srgbClr val="0F2240"/>
+                </a:solidFill>
+                <a:latin typeface="+mn-lt"/>
+              </a:rPr>
+              <a:t>Threshold:  R</a:t>
+            </a:r>
+            <a:r>
+              <a:rPr lang="en-GB" sz="2600" b="1" baseline="-25000" dirty="0">
+                <a:solidFill>
+                  <a:srgbClr val="0F2240"/>
+                </a:solidFill>
+                <a:latin typeface="+mn-lt"/>
+              </a:rPr>
+              <a:t>0</a:t>
+            </a:r>
+            <a:r>
+              <a:rPr lang="en-GB" sz="2600" b="1" dirty="0">
+                <a:solidFill>
+                  <a:srgbClr val="0F2240"/>
+                </a:solidFill>
+                <a:latin typeface="+mn-lt"/>
+              </a:rPr>
+              <a:t xml:space="preserve"> s* = 1</a:t>
+            </a:r>
+          </a:p>
+        </p:txBody>
+      </p:sp>
+      <p:graphicFrame>
+        <p:nvGraphicFramePr>
+          <p:cNvPr id="107" name="Eigenvalue table"/>
+          <p:cNvGraphicFramePr>
+            <a:graphicFrameLocks noGrp="1"/>
+          </p:cNvGraphicFramePr>
+          <p:nvPr/>
+        </p:nvGraphicFramePr>
+        <p:xfrm>
+          <a:off x="6446520" y="3580000"/>
+          <a:ext cx="4754880" cy="1650000"/>
+        </p:xfrm>
+        <a:graphic>
+          <a:graphicData uri="http://schemas.openxmlformats.org/drawingml/2006/table">
+            <a:tbl>
+              <a:tblPr firstRow="1"/>
+              <a:tblGrid>
+                <a:gridCol w="1000000"/>
+                <a:gridCol w="2354880"/>
+                <a:gridCol w="1400000"/>
+              </a:tblGrid>
+              <a:tr h="330000">
+                <a:tc>
+                  <a:txBody>
+                    <a:bodyPr/>
+                    <a:lstStyle/>
+                    <a:p>
+                      <a:pPr algn="ctr">
+                        <a:buNone/>
+                      </a:pPr>
+                      <a:r>
+                        <a:rPr lang="en-GB" sz="1500" b="1" dirty="0">
+                          <a:solidFill>
+                            <a:srgbClr val="FFFFFF"/>
+                          </a:solidFill>
+                          <a:latin typeface="+mn-lt"/>
+                        </a:rPr>
+                        <a:t>s*</a:t>
+                      </a:r>
+                    </a:p>
+                  </a:txBody>
+                  <a:tcPr marL="64008" marR="64008" marT="27432" marB="27432" anchor="ctr">
+                    <a:lnL w="9525">
+                      <a:solidFill>
+                        <a:srgbClr val="CBD5E1"/>
+                      </a:solidFill>
+                    </a:lnL>
+                    <a:lnR w="9525">
+                      <a:solidFill>
+                        <a:srgbClr val="CBD5E1"/>
+                      </a:solidFill>
+                    </a:lnR>
+                    <a:lnT w="9525">
+                      <a:solidFill>
+                        <a:srgbClr val="CBD5E1"/>
+                      </a:solidFill>
+                    </a:lnT>
+                    <a:lnB w="9525">
+                      <a:solidFill>
+                        <a:srgbClr val="CBD5E1"/>
+                      </a:solidFill>
+                    </a:lnB>
+                    <a:solidFill>
+                      <a:srgbClr val="0F2240"/>
+                    </a:solidFill>
+                  </a:tcPr>
+                </a:tc>
+                <a:tc>
+                  <a:txBody>
+                    <a:bodyPr/>
+                    <a:lstStyle/>
+                    <a:p>
+                      <a:pPr algn="ctr">
+                        <a:buNone/>
+                      </a:pPr>
+                      <a:r>
+                        <a:rPr lang="en-GB" sz="1500" b="1" dirty="0">
+                          <a:solidFill>
+                            <a:srgbClr val="FFFFFF"/>
+                          </a:solidFill>
+                          <a:latin typeface="+mn-lt"/>
+                        </a:rPr>
+                        <a:t>eigenvalues (e, i block)</a:t>
+                      </a:r>
+                    </a:p>
+                  </a:txBody>
+                  <a:tcPr marL="64008" marR="64008" marT="27432" marB="27432" anchor="ctr">
+                    <a:lnL w="9525">
+                      <a:solidFill>
+                        <a:srgbClr val="CBD5E1"/>
+                      </a:solidFill>
+                    </a:lnL>
+                    <a:lnR w="9525">
+                      <a:solidFill>
+                        <a:srgbClr val="CBD5E1"/>
+                      </a:solidFill>
+                    </a:lnR>
+                    <a:lnT w="9525">
+                      <a:solidFill>
+                        <a:srgbClr val="CBD5E1"/>
+                      </a:solidFill>
+                    </a:lnT>
+                    <a:lnB w="9525">
+                      <a:solidFill>
+                        <a:srgbClr val="CBD5E1"/>
+                      </a:solidFill>
+                    </a:lnB>
+                    <a:solidFill>
+                      <a:srgbClr val="0F2240"/>
+                    </a:solidFill>
+                  </a:tcPr>
+                </a:tc>
+                <a:tc>
+                  <a:txBody>
+                    <a:bodyPr/>
+                    <a:lstStyle/>
+                    <a:p>
+                      <a:pPr algn="ctr">
+                        <a:buNone/>
+                      </a:pPr>
+                      <a:r>
+                        <a:rPr lang="en-GB" sz="1500" b="1" dirty="0">
+                          <a:solidFill>
+                            <a:srgbClr val="FFFFFF"/>
+                          </a:solidFill>
+                          <a:latin typeface="+mn-lt"/>
+                        </a:rPr>
+                        <a:t>result</a:t>
+                      </a:r>
+                    </a:p>
+                  </a:txBody>
+                  <a:tcPr marL="64008" marR="64008" marT="27432" marB="27432" anchor="ctr">
+                    <a:lnL w="9525">
+                      <a:solidFill>
+                        <a:srgbClr val="CBD5E1"/>
+                      </a:solidFill>
+                    </a:lnL>
+                    <a:lnR w="9525">
+                      <a:solidFill>
+                        <a:srgbClr val="CBD5E1"/>
+                      </a:solidFill>
+                    </a:lnR>
+                    <a:lnT w="9525">
+                      <a:solidFill>
+                        <a:srgbClr val="CBD5E1"/>
+                      </a:solidFill>
+                    </a:lnT>
+                    <a:lnB w="9525">
+                      <a:solidFill>
+                        <a:srgbClr val="CBD5E1"/>
+                      </a:solidFill>
+                    </a:lnB>
+                    <a:solidFill>
+                      <a:srgbClr val="0F2240"/>
+                    </a:solidFill>
+                  </a:tcPr>
+                </a:tc>
+              </a:tr>
+              <a:tr h="330000">
+                <a:tc>
+                  <a:txBody>
+                    <a:bodyPr/>
+                    <a:lstStyle/>
+                    <a:p>
+                      <a:pPr algn="ctr">
+                        <a:buNone/>
+                      </a:pPr>
+                      <a:r>
+                        <a:rPr lang="en-GB" sz="1500" b="0" dirty="0">
+                          <a:solidFill>
+                            <a:srgbClr val="1E293B"/>
+                          </a:solidFill>
+                          <a:latin typeface="+mn-lt"/>
+                        </a:rPr>
+                        <a:t>1.00</a:t>
+                      </a:r>
+                    </a:p>
+                  </a:txBody>
+                  <a:tcPr marL="64008" marR="64008" marT="27432" marB="27432" anchor="ctr">
+                    <a:lnL w="9525">
+                      <a:solidFill>
+                        <a:srgbClr val="CBD5E1"/>
+                      </a:solidFill>
+                    </a:lnL>
+                    <a:lnR w="9525">
+                      <a:solidFill>
+                        <a:srgbClr val="CBD5E1"/>
+                      </a:solidFill>
+                    </a:lnR>
+                    <a:lnT w="9525">
+                      <a:solidFill>
+                        <a:srgbClr val="CBD5E1"/>
+                      </a:solidFill>
+                    </a:lnT>
+                    <a:lnB w="9525">
+                      <a:solidFill>
+                        <a:srgbClr val="CBD5E1"/>
+                      </a:solidFill>
+                    </a:lnB>
+                    <a:solidFill>
+                      <a:srgbClr val="FFFFFF"/>
+                    </a:solidFill>
+                  </a:tcPr>
+                </a:tc>
+                <a:tc>
+                  <a:txBody>
+                    <a:bodyPr/>
+                    <a:lstStyle/>
+                    <a:p>
+                      <a:pPr algn="ctr">
+                        <a:buNone/>
+                      </a:pPr>
+                      <a:r>
+                        <a:rPr lang="en-GB" sz="1500" b="0" dirty="0">
+                          <a:solidFill>
+                            <a:srgbClr val="1E293B"/>
+                          </a:solidFill>
+                          <a:latin typeface="+mn-lt"/>
+                        </a:rPr>
+                        <a:t>−0.412,  +0.063</a:t>
+                      </a:r>
+                    </a:p>
+                  </a:txBody>
+                  <a:tcPr marL="64008" marR="64008" marT="27432" marB="27432" anchor="ctr">
+                    <a:lnL w="9525">
+                      <a:solidFill>
+                        <a:srgbClr val="CBD5E1"/>
+                      </a:solidFill>
+                    </a:lnL>
+                    <a:lnR w="9525">
+                      <a:solidFill>
+                        <a:srgbClr val="CBD5E1"/>
+                      </a:solidFill>
+                    </a:lnR>
+                    <a:lnT w="9525">
+                      <a:solidFill>
+                        <a:srgbClr val="CBD5E1"/>
+                      </a:solidFill>
+                    </a:lnT>
+                    <a:lnB w="9525">
+                      <a:solidFill>
+                        <a:srgbClr val="CBD5E1"/>
+                      </a:solidFill>
+                    </a:lnB>
+                    <a:solidFill>
+                      <a:srgbClr val="FFFFFF"/>
+                    </a:solidFill>
+                  </a:tcPr>
+                </a:tc>
+                <a:tc>
+                  <a:txBody>
+                    <a:bodyPr/>
+                    <a:lstStyle/>
+                    <a:p>
+                      <a:pPr algn="ctr">
+                        <a:buNone/>
+                      </a:pPr>
+                      <a:r>
+                        <a:rPr lang="en-GB" sz="1500" b="1" dirty="0">
+                          <a:solidFill>
+                            <a:srgbClr val="991B1B"/>
+                          </a:solidFill>
+                          <a:latin typeface="+mn-lt"/>
+                        </a:rPr>
+                        <a:t>unstable</a:t>
+                      </a:r>
+                    </a:p>
+                  </a:txBody>
+                  <a:tcPr marL="64008" marR="64008" marT="27432" marB="27432" anchor="ctr">
+                    <a:lnL w="9525">
+                      <a:solidFill>
+                        <a:srgbClr val="CBD5E1"/>
+                      </a:solidFill>
+                    </a:lnL>
+                    <a:lnR w="9525">
+                      <a:solidFill>
+                        <a:srgbClr val="CBD5E1"/>
+                      </a:solidFill>
+                    </a:lnR>
+                    <a:lnT w="9525">
+                      <a:solidFill>
+                        <a:srgbClr val="CBD5E1"/>
+                      </a:solidFill>
+                    </a:lnT>
+                    <a:lnB w="9525">
+                      <a:solidFill>
+                        <a:srgbClr val="CBD5E1"/>
+                      </a:solidFill>
+                    </a:lnB>
+                    <a:solidFill>
+                      <a:srgbClr val="FDE2E2"/>
+                    </a:solidFill>
+                  </a:tcPr>
+                </a:tc>
+              </a:tr>
+              <a:tr h="330000">
+                <a:tc>
+                  <a:txBody>
+                    <a:bodyPr/>
+                    <a:lstStyle/>
+                    <a:p>
+                      <a:pPr algn="ctr">
+                        <a:buNone/>
+                      </a:pPr>
+                      <a:r>
+                        <a:rPr lang="en-GB" sz="1500" b="0" dirty="0">
+                          <a:solidFill>
+                            <a:srgbClr val="1E293B"/>
+                          </a:solidFill>
+                          <a:latin typeface="+mn-lt"/>
+                        </a:rPr>
+                        <a:t>0.75</a:t>
+                      </a:r>
+                    </a:p>
+                  </a:txBody>
+                  <a:tcPr marL="64008" marR="64008" marT="27432" marB="27432" anchor="ctr">
+                    <a:lnL w="9525">
+                      <a:solidFill>
+                        <a:srgbClr val="CBD5E1"/>
+                      </a:solidFill>
+                    </a:lnL>
+                    <a:lnR w="9525">
+                      <a:solidFill>
+                        <a:srgbClr val="CBD5E1"/>
+                      </a:solidFill>
+                    </a:lnR>
+                    <a:lnT w="9525">
+                      <a:solidFill>
+                        <a:srgbClr val="CBD5E1"/>
+                      </a:solidFill>
+                    </a:lnT>
+                    <a:lnB w="9525">
+                      <a:solidFill>
+                        <a:srgbClr val="CBD5E1"/>
+                      </a:solidFill>
+                    </a:lnB>
+                    <a:solidFill>
+                      <a:srgbClr val="FFFFFF"/>
+                    </a:solidFill>
+                  </a:tcPr>
+                </a:tc>
+                <a:tc>
+                  <a:txBody>
+                    <a:bodyPr/>
+                    <a:lstStyle/>
+                    <a:p>
+                      <a:pPr algn="ctr">
+                        <a:buNone/>
+                      </a:pPr>
+                      <a:r>
+                        <a:rPr lang="en-GB" sz="1500" b="0" dirty="0">
+                          <a:solidFill>
+                            <a:srgbClr val="1E293B"/>
+                          </a:solidFill>
+                          <a:latin typeface="+mn-lt"/>
+                        </a:rPr>
+                        <a:t>−0.383,  +0.034</a:t>
+                      </a:r>
+                    </a:p>
+                  </a:txBody>
+                  <a:tcPr marL="64008" marR="64008" marT="27432" marB="27432" anchor="ctr">
+                    <a:lnL w="9525">
+                      <a:solidFill>
+                        <a:srgbClr val="CBD5E1"/>
+                      </a:solidFill>
+                    </a:lnL>
+                    <a:lnR w="9525">
+                      <a:solidFill>
+                        <a:srgbClr val="CBD5E1"/>
+                      </a:solidFill>
+                    </a:lnR>
+                    <a:lnT w="9525">
+                      <a:solidFill>
+                        <a:srgbClr val="CBD5E1"/>
+                      </a:solidFill>
+                    </a:lnT>
+                    <a:lnB w="9525">
+                      <a:solidFill>
+                        <a:srgbClr val="CBD5E1"/>
+                      </a:solidFill>
+                    </a:lnB>
+                    <a:solidFill>
+                      <a:srgbClr val="FFFFFF"/>
+                    </a:solidFill>
+                  </a:tcPr>
+                </a:tc>
+                <a:tc>
+                  <a:txBody>
+                    <a:bodyPr/>
+                    <a:lstStyle/>
+                    <a:p>
+                      <a:pPr algn="ctr">
+                        <a:buNone/>
+                      </a:pPr>
+                      <a:r>
+                        <a:rPr lang="en-GB" sz="1500" b="1" dirty="0">
+                          <a:solidFill>
+                            <a:srgbClr val="991B1B"/>
+                          </a:solidFill>
+                          <a:latin typeface="+mn-lt"/>
+                        </a:rPr>
+                        <a:t>unstable</a:t>
+                      </a:r>
+                    </a:p>
+                  </a:txBody>
+                  <a:tcPr marL="64008" marR="64008" marT="27432" marB="27432" anchor="ctr">
+                    <a:lnL w="9525">
+                      <a:solidFill>
+                        <a:srgbClr val="CBD5E1"/>
+                      </a:solidFill>
+                    </a:lnL>
+                    <a:lnR w="9525">
+                      <a:solidFill>
+                        <a:srgbClr val="CBD5E1"/>
+                      </a:solidFill>
+                    </a:lnR>
+                    <a:lnT w="9525">
+                      <a:solidFill>
+                        <a:srgbClr val="CBD5E1"/>
+                      </a:solidFill>
+                    </a:lnT>
+                    <a:lnB w="9525">
+                      <a:solidFill>
+                        <a:srgbClr val="CBD5E1"/>
+                      </a:solidFill>
+                    </a:lnB>
+                    <a:solidFill>
+                      <a:srgbClr val="FDE2E2"/>
+                    </a:solidFill>
+                  </a:tcPr>
+                </a:tc>
+              </a:tr>
+              <a:tr h="330000">
+                <a:tc>
+                  <a:txBody>
+                    <a:bodyPr/>
+                    <a:lstStyle/>
+                    <a:p>
+                      <a:pPr algn="ctr">
+                        <a:buNone/>
+                      </a:pPr>
+                      <a:r>
+                        <a:rPr lang="en-GB" sz="1500" b="0" dirty="0">
+                          <a:solidFill>
+                            <a:srgbClr val="1E293B"/>
+                          </a:solidFill>
+                          <a:latin typeface="+mn-lt"/>
+                        </a:rPr>
+                        <a:t>0.40</a:t>
+                      </a:r>
+                    </a:p>
+                  </a:txBody>
+                  <a:tcPr marL="64008" marR="64008" marT="27432" marB="27432" anchor="ctr">
+                    <a:lnL w="9525">
+                      <a:solidFill>
+                        <a:srgbClr val="CBD5E1"/>
+                      </a:solidFill>
+                    </a:lnL>
+                    <a:lnR w="9525">
+                      <a:solidFill>
+                        <a:srgbClr val="CBD5E1"/>
+                      </a:solidFill>
+                    </a:lnR>
+                    <a:lnT w="9525">
+                      <a:solidFill>
+                        <a:srgbClr val="CBD5E1"/>
+                      </a:solidFill>
+                    </a:lnT>
+                    <a:lnB w="9525">
+                      <a:solidFill>
+                        <a:srgbClr val="CBD5E1"/>
+                      </a:solidFill>
+                    </a:lnB>
+                    <a:solidFill>
+                      <a:srgbClr val="FFFFFF"/>
+                    </a:solidFill>
+                  </a:tcPr>
+                </a:tc>
+                <a:tc>
+                  <a:txBody>
+                    <a:bodyPr/>
+                    <a:lstStyle/>
+                    <a:p>
+                      <a:pPr algn="ctr">
+                        <a:buNone/>
+                      </a:pPr>
+                      <a:r>
+                        <a:rPr lang="en-GB" sz="1500" b="0" dirty="0">
+                          <a:solidFill>
+                            <a:srgbClr val="1E293B"/>
+                          </a:solidFill>
+                          <a:latin typeface="+mn-lt"/>
+                        </a:rPr>
+                        <a:t>−0.334,  −0.016</a:t>
+                      </a:r>
+                    </a:p>
+                  </a:txBody>
+                  <a:tcPr marL="64008" marR="64008" marT="27432" marB="27432" anchor="ctr">
+                    <a:lnL w="9525">
+                      <a:solidFill>
+                        <a:srgbClr val="CBD5E1"/>
+                      </a:solidFill>
+                    </a:lnL>
+                    <a:lnR w="9525">
+                      <a:solidFill>
+                        <a:srgbClr val="CBD5E1"/>
+                      </a:solidFill>
+                    </a:lnR>
+                    <a:lnT w="9525">
+                      <a:solidFill>
+                        <a:srgbClr val="CBD5E1"/>
+                      </a:solidFill>
+                    </a:lnT>
+                    <a:lnB w="9525">
+                      <a:solidFill>
+                        <a:srgbClr val="CBD5E1"/>
+                      </a:solidFill>
+                    </a:lnB>
+                    <a:solidFill>
+                      <a:srgbClr val="FFFFFF"/>
+                    </a:solidFill>
+                  </a:tcPr>
+                </a:tc>
+                <a:tc>
+                  <a:txBody>
+                    <a:bodyPr/>
+                    <a:lstStyle/>
+                    <a:p>
+                      <a:pPr algn="ctr">
+                        <a:buNone/>
+                      </a:pPr>
+                      <a:r>
+                        <a:rPr lang="en-GB" sz="1500" b="1" dirty="0">
+                          <a:solidFill>
+                            <a:srgbClr val="1E3A8A"/>
+                          </a:solidFill>
+                          <a:latin typeface="+mn-lt"/>
+                        </a:rPr>
+                        <a:t>stable</a:t>
+                      </a:r>
+                    </a:p>
+                  </a:txBody>
+                  <a:tcPr marL="64008" marR="64008" marT="27432" marB="27432" anchor="ctr">
+                    <a:lnL w="9525">
+                      <a:solidFill>
+                        <a:srgbClr val="CBD5E1"/>
+                      </a:solidFill>
+                    </a:lnL>
+                    <a:lnR w="9525">
+                      <a:solidFill>
+                        <a:srgbClr val="CBD5E1"/>
+                      </a:solidFill>
+                    </a:lnR>
+                    <a:lnT w="9525">
+                      <a:solidFill>
+                        <a:srgbClr val="CBD5E1"/>
+                      </a:solidFill>
+                    </a:lnT>
+                    <a:lnB w="9525">
+                      <a:solidFill>
+                        <a:srgbClr val="CBD5E1"/>
+                      </a:solidFill>
+                    </a:lnB>
+                    <a:solidFill>
+                      <a:srgbClr val="DBEAFE"/>
+                    </a:solidFill>
+                  </a:tcPr>
+                </a:tc>
+              </a:tr>
+              <a:tr h="330000">
+                <a:tc>
+                  <a:txBody>
+                    <a:bodyPr/>
+                    <a:lstStyle/>
+                    <a:p>
+                      <a:pPr algn="ctr">
+                        <a:buNone/>
+                      </a:pPr>
+                      <a:r>
+                        <a:rPr lang="en-GB" sz="1500" b="0" dirty="0">
+                          <a:solidFill>
+                            <a:srgbClr val="1E293B"/>
+                          </a:solidFill>
+                          <a:latin typeface="+mn-lt"/>
+                        </a:rPr>
+                        <a:t>0.25</a:t>
+                      </a:r>
+                    </a:p>
+                  </a:txBody>
+                  <a:tcPr marL="64008" marR="64008" marT="27432" marB="27432" anchor="ctr">
+                    <a:lnL w="9525">
+                      <a:solidFill>
+                        <a:srgbClr val="CBD5E1"/>
+                      </a:solidFill>
+                    </a:lnL>
+                    <a:lnR w="9525">
+                      <a:solidFill>
+                        <a:srgbClr val="CBD5E1"/>
+                      </a:solidFill>
+                    </a:lnR>
+                    <a:lnT w="9525">
+                      <a:solidFill>
+                        <a:srgbClr val="CBD5E1"/>
+                      </a:solidFill>
+                    </a:lnT>
+                    <a:lnB w="9525">
+                      <a:solidFill>
+                        <a:srgbClr val="CBD5E1"/>
+                      </a:solidFill>
+                    </a:lnB>
+                    <a:solidFill>
+                      <a:srgbClr val="FFFFFF"/>
+                    </a:solidFill>
+                  </a:tcPr>
+                </a:tc>
+                <a:tc>
+                  <a:txBody>
+                    <a:bodyPr/>
+                    <a:lstStyle/>
+                    <a:p>
+                      <a:pPr algn="ctr">
+                        <a:buNone/>
+                      </a:pPr>
+                      <a:r>
+                        <a:rPr lang="en-GB" sz="1500" b="0" dirty="0">
+                          <a:solidFill>
+                            <a:srgbClr val="1E293B"/>
+                          </a:solidFill>
+                          <a:latin typeface="+mn-lt"/>
+                        </a:rPr>
+                        <a:t>−0.307,  −0.042</a:t>
+                      </a:r>
+                    </a:p>
+                  </a:txBody>
+                  <a:tcPr marL="64008" marR="64008" marT="27432" marB="27432" anchor="ctr">
+                    <a:lnL w="9525">
+                      <a:solidFill>
+                        <a:srgbClr val="CBD5E1"/>
+                      </a:solidFill>
+                    </a:lnL>
+                    <a:lnR w="9525">
+                      <a:solidFill>
+                        <a:srgbClr val="CBD5E1"/>
+                      </a:solidFill>
+                    </a:lnR>
+                    <a:lnT w="9525">
+                      <a:solidFill>
+                        <a:srgbClr val="CBD5E1"/>
+                      </a:solidFill>
+                    </a:lnT>
+                    <a:lnB w="9525">
+                      <a:solidFill>
+                        <a:srgbClr val="CBD5E1"/>
+                      </a:solidFill>
+                    </a:lnB>
+                    <a:solidFill>
+                      <a:srgbClr val="FFFFFF"/>
+                    </a:solidFill>
+                  </a:tcPr>
+                </a:tc>
+                <a:tc>
+                  <a:txBody>
+                    <a:bodyPr/>
+                    <a:lstStyle/>
+                    <a:p>
+                      <a:pPr algn="ctr">
+                        <a:buNone/>
+                      </a:pPr>
+                      <a:r>
+                        <a:rPr lang="en-GB" sz="1500" b="1" dirty="0">
+                          <a:solidFill>
+                            <a:srgbClr val="1E3A8A"/>
+                          </a:solidFill>
+                          <a:latin typeface="+mn-lt"/>
+                        </a:rPr>
+                        <a:t>stable</a:t>
+                      </a:r>
+                    </a:p>
+                  </a:txBody>
+                  <a:tcPr marL="64008" marR="64008" marT="27432" marB="27432" anchor="ctr">
+                    <a:lnL w="9525">
+                      <a:solidFill>
+                        <a:srgbClr val="CBD5E1"/>
+                      </a:solidFill>
+                    </a:lnL>
+                    <a:lnR w="9525">
+                      <a:solidFill>
+                        <a:srgbClr val="CBD5E1"/>
+                      </a:solidFill>
+                    </a:lnR>
+                    <a:lnT w="9525">
+                      <a:solidFill>
+                        <a:srgbClr val="CBD5E1"/>
+                      </a:solidFill>
+                    </a:lnT>
+                    <a:lnB w="9525">
+                      <a:solidFill>
+                        <a:srgbClr val="CBD5E1"/>
+                      </a:solidFill>
+                    </a:lnB>
+                    <a:solidFill>
+                      <a:srgbClr val="DBEAFE"/>
+                    </a:solidFill>
+                  </a:tcPr>
+                </a:tc>
+              </a:tr>
+            </a:tbl>
+          </a:graphicData>
+        </a:graphic>
+      </p:graphicFrame>
+      <p:sp>
+        <p:nvSpPr>
+          <p:cNvPr id="108" name="Stability points"/>
+          <p:cNvSpPr txBox="1"/>
+          <p:nvPr/>
+        </p:nvSpPr>
+        <p:spPr>
+          <a:xfrm>
+            <a:off x="6446520" y="5350000"/>
+            <a:ext cx="4754880" cy="700000"/>
+          </a:xfrm>
+          <a:prstGeom prst="rect">
+            <a:avLst/>
+          </a:prstGeom>
+          <a:noFill/>
+        </p:spPr>
+        <p:txBody>
+          <a:bodyPr wrap="square" lIns="0" tIns="0" rIns="0" bIns="0" anchor="t">
+            <a:noAutofit/>
+          </a:bodyPr>
+          <a:lstStyle/>
+          <a:p>
+            <a:pPr algn="l" marL="228600" indent="-228600">
               <a:spcAft>
-                <a:spcPts val="400"/>
+                <a:spcPts val="500"/>
               </a:spcAft>
-              <a:defRPr sz="1100">
+              <a:buClr>
+                <a:srgbClr val="1A56A0"/>
+              </a:buClr>
+              <a:buFont typeface="Arial"/>
+              <a:buChar char="•"/>
+            </a:pPr>
+            <a:r>
+              <a:rPr lang="en-GB" sz="1400" b="0" dirty="0">
                 <a:solidFill>
                   <a:srgbClr val="1E293B"/>
                 </a:solidFill>
-              </a:defRPr>
-            </a:pPr>
-            <a:r>
-              <a:t>- Every equilibrium is disease-free, (s*, 0, 0, r*, d*). No births and lasting immunity, so every epidemic burns out.</a:t>
-            </a:r>
-          </a:p>
-          <a:p>
-            <a:pPr>
-              <a:spcAft>
-                <a:spcPts val="400"/>
-              </a:spcAft>
-              <a:defRPr sz="1100">
+                <a:latin typeface="+mn-lt"/>
+              </a:rPr>
+              <a:t>Stable, not asymptotically: three eigenvalues are 0.</a:t>
+            </a:r>
+          </a:p>
+          <a:p>
+            <a:pPr algn="l" marL="228600" indent="-228600">
+              <a:buClr>
+                <a:srgbClr val="1A56A0"/>
+              </a:buClr>
+              <a:buFont typeface="Arial"/>
+              <a:buChar char="•"/>
+            </a:pPr>
+            <a:r>
+              <a:rPr lang="en-GB" sz="1400" b="0" dirty="0">
                 <a:solidFill>
                   <a:srgbClr val="1E293B"/>
                 </a:solidFill>
-              </a:defRPr>
-            </a:pPr>
-            <a:r>
-              <a:t>- Jacobian: three zero eigenvalues (sliding along the family of equilibria) and two roots of λ² + (σ+γ+μ)λ + σ(γ+μ)(1 − R0·s*) = 0.</a:t>
-            </a:r>
-          </a:p>
-          <a:p>
-            <a:pPr>
-              <a:spcAft>
-                <a:spcPts val="400"/>
-              </a:spcAft>
-              <a:defRPr sz="1100">
+                <a:latin typeface="+mn-lt"/>
+              </a:rPr>
+              <a:t>Early growth λ</a:t>
+            </a:r>
+            <a:r>
+              <a:rPr lang="en-GB" sz="1400" b="0" baseline="-25000" dirty="0">
                 <a:solidFill>
                   <a:srgbClr val="1E293B"/>
                 </a:solidFill>
-              </a:defRPr>
-            </a:pPr>
-            <a:r>
-              <a:t>- R0·s* &lt; 1: both roots negative, a few new cases die out (stable, though not asymptotically, because of the zero eigenvalues). R0·s* &gt; 1: one root positive, an outbreak grows.</a:t>
-            </a:r>
-          </a:p>
-          <a:p>
-            <a:pPr>
-              <a:spcAft>
-                <a:spcPts val="400"/>
-              </a:spcAft>
-              <a:defRPr sz="1100">
+                <a:latin typeface="+mn-lt"/>
+              </a:rPr>
+              <a:t>+</a:t>
+            </a:r>
+            <a:r>
+              <a:rPr lang="en-GB" sz="1400" b="0" dirty="0">
                 <a:solidFill>
                   <a:srgbClr val="1E293B"/>
                 </a:solidFill>
-              </a:defRPr>
-            </a:pPr>
-            <a:r>
-              <a:t>- The positive root is the early growth rate: 0.0627 per day (doubling in about 11 days). A simulation matches it to 0.003%.</a:t>
+                <a:latin typeface="+mn-lt"/>
+              </a:rPr>
+              <a:t xml:space="preserve"> = 0.0627/day (doubling ≈ 11 days).</a:t>
             </a:r>
           </a:p>
         </p:txBody>
@@ -5445,6 +6477,12 @@
               </a:defRPr>
             </a:pPr>
             <a:r>
+              <a:rPr lang="en-GB" sz="2200" b="1" dirty="0">
+                <a:solidFill>
+                  <a:srgbClr val="0F2240"/>
+                </a:solidFill>
+                <a:latin typeface="+mn-lt"/>
+              </a:rPr>
               <a:t>Final-Size Relation and Sensitivity Analysis</a:t>
             </a:r>
           </a:p>
@@ -5497,89 +6535,6 @@
       </p:sp>
       <p:sp>
         <p:nvSpPr>
-          <p:cNvPr id="4" name="TextBox 3"/>
-          <p:cNvSpPr txBox="1"/>
-          <p:nvPr/>
-        </p:nvSpPr>
-        <p:spPr>
-          <a:xfrm>
-            <a:off x="960120" y="1828800"/>
-            <a:ext cx="4663440" cy="4206240"/>
-          </a:xfrm>
-          <a:prstGeom prst="rect">
-            <a:avLst/>
-          </a:prstGeom>
-          <a:noFill/>
-        </p:spPr>
-        <p:txBody>
-          <a:bodyPr wrap="square" tIns="0" bIns="0" lIns="0" rIns="0">
-            <a:spAutoFit/>
-          </a:bodyPr>
-          <a:lstStyle/>
-          <a:p>
-            <a:pPr>
-              <a:spcAft>
-                <a:spcPts val="800"/>
-              </a:spcAft>
-              <a:defRPr sz="1500" b="1">
-                <a:solidFill>
-                  <a:srgbClr val="0F2240"/>
-                </a:solidFill>
-              </a:defRPr>
-            </a:pPr>
-            <a:r>
-              <a:t>Final-Size Relation (constant β)</a:t>
-            </a:r>
-          </a:p>
-          <a:p>
-            <a:pPr>
-              <a:spcAft>
-                <a:spcPts val="400"/>
-              </a:spcAft>
-              <a:defRPr sz="1100">
-                <a:solidFill>
-                  <a:srgbClr val="1E293B"/>
-                </a:solidFill>
-              </a:defRPr>
-            </a:pPr>
-            <a:r>
-              <a:t>- From ds/d(r+d) = −R0·s: ln(s0/s∞) = R0(1 − s∞ − r0 − d0), and final deaths d∞ = d0 + μ/(γ+μ)·(1 − s∞ − r0 − d0).</a:t>
-            </a:r>
-          </a:p>
-          <a:p>
-            <a:pPr>
-              <a:spcAft>
-                <a:spcPts val="400"/>
-              </a:spcAft>
-              <a:defRPr sz="1100">
-                <a:solidFill>
-                  <a:srgbClr val="1E293B"/>
-                </a:solidFill>
-              </a:defRPr>
-            </a:pPr>
-            <a:r>
-              <a:t>- At R0 = 2: about 80% are infected by the end (s∞ = 0.1998) and 33% die (d∞ = 0.3295).</a:t>
-            </a:r>
-          </a:p>
-          <a:p>
-            <a:pPr>
-              <a:spcAft>
-                <a:spcPts val="400"/>
-              </a:spcAft>
-              <a:defRPr sz="1100">
-                <a:solidFill>
-                  <a:srgbClr val="1E293B"/>
-                </a:solidFill>
-              </a:defRPr>
-            </a:pPr>
-            <a:r>
-              <a:t>- Formula and ODE agree to about 10⁻¹² for R0 from 0.8 to 3.5, once the ODE runs until the epidemic is over (e+i &lt; 10⁻¹³). Stopping at day 250 left errors up to 0.6%.</a:t>
-            </a:r>
-          </a:p>
-        </p:txBody>
-      </p:sp>
-      <p:sp>
-        <p:nvSpPr>
           <p:cNvPr id="5" name="Rounded Rectangle 4"/>
           <p:cNvSpPr/>
           <p:nvPr/>
@@ -5625,14 +6580,14 @@
       </p:sp>
       <p:sp>
         <p:nvSpPr>
-          <p:cNvPr id="6" name="TextBox 5"/>
+          <p:cNvPr id="109" name="Heading"/>
           <p:cNvSpPr txBox="1"/>
           <p:nvPr/>
         </p:nvSpPr>
         <p:spPr>
           <a:xfrm>
-            <a:off x="6446520" y="1828800"/>
-            <a:ext cx="4754880" cy="4206240"/>
+            <a:off x="960120" y="1828800"/>
+            <a:ext cx="4663440" cy="420000"/>
           </a:xfrm>
           <a:prstGeom prst="rect">
             <a:avLst/>
@@ -5640,83 +6595,1683 @@
           <a:noFill/>
         </p:spPr>
         <p:txBody>
-          <a:bodyPr wrap="square" tIns="0" bIns="0" lIns="0" rIns="0">
-            <a:spAutoFit/>
+          <a:bodyPr wrap="square" lIns="0" tIns="0" rIns="0" bIns="0" anchor="t">
+            <a:noAutofit/>
           </a:bodyPr>
           <a:lstStyle/>
           <a:p>
-            <a:pPr>
+            <a:pPr algn="l">
+              <a:buNone/>
+            </a:pPr>
+            <a:r>
+              <a:rPr lang="en-GB" sz="2000" b="1" dirty="0">
+                <a:solidFill>
+                  <a:srgbClr val="0F2240"/>
+                </a:solidFill>
+                <a:latin typeface="+mn-lt"/>
+              </a:rPr>
+              <a:t>Final-size relation (constant β)</a:t>
+            </a:r>
+          </a:p>
+        </p:txBody>
+      </p:sp>
+      <p:sp>
+        <p:nvSpPr>
+          <p:cNvPr id="110" name="Final size callout"/>
+          <p:cNvSpPr/>
+          <p:nvPr/>
+        </p:nvSpPr>
+        <p:spPr>
+          <a:xfrm>
+            <a:off x="960120" y="2330000"/>
+            <a:ext cx="4663440" cy="800000"/>
+          </a:xfrm>
+          <a:prstGeom prst="roundRect">
+            <a:avLst>
+              <a:gd name="adj" fmla="val 12000"/>
+            </a:avLst>
+          </a:prstGeom>
+          <a:solidFill>
+            <a:srgbClr val="EEF4FB"/>
+          </a:solidFill>
+          <a:ln>
+            <a:noFill/>
+          </a:ln>
+        </p:spPr>
+        <p:txBody>
+          <a:bodyPr wrap="square" lIns="91440" tIns="45720" rIns="91440" bIns="45720" anchor="ctr">
+            <a:normAutofit/>
+          </a:bodyPr>
+          <a:lstStyle/>
+          <a:p>
+            <a:pPr algn="ctr">
+              <a:buNone/>
+            </a:pPr>
+            <a:r>
+              <a:rPr lang="en-GB" sz="2400" b="1" dirty="0">
+                <a:solidFill>
+                  <a:srgbClr val="0F2240"/>
+                </a:solidFill>
+                <a:latin typeface="+mn-lt"/>
+              </a:rPr>
+              <a:t>ln(s</a:t>
+            </a:r>
+            <a:r>
+              <a:rPr lang="en-GB" sz="2400" b="1" baseline="-25000" dirty="0">
+                <a:solidFill>
+                  <a:srgbClr val="0F2240"/>
+                </a:solidFill>
+                <a:latin typeface="+mn-lt"/>
+              </a:rPr>
+              <a:t>0</a:t>
+            </a:r>
+            <a:r>
+              <a:rPr lang="en-GB" sz="2400" b="1" dirty="0">
+                <a:solidFill>
+                  <a:srgbClr val="0F2240"/>
+                </a:solidFill>
+                <a:latin typeface="+mn-lt"/>
+              </a:rPr>
+              <a:t>/s</a:t>
+            </a:r>
+            <a:r>
+              <a:rPr lang="en-GB" sz="2400" b="1" baseline="-25000" dirty="0">
+                <a:solidFill>
+                  <a:srgbClr val="0F2240"/>
+                </a:solidFill>
+                <a:latin typeface="+mn-lt"/>
+              </a:rPr>
+              <a:t>∞</a:t>
+            </a:r>
+            <a:r>
+              <a:rPr lang="en-GB" sz="2400" b="1" dirty="0">
+                <a:solidFill>
+                  <a:srgbClr val="0F2240"/>
+                </a:solidFill>
+                <a:latin typeface="+mn-lt"/>
+              </a:rPr>
+              <a:t>) = R</a:t>
+            </a:r>
+            <a:r>
+              <a:rPr lang="en-GB" sz="2400" b="1" baseline="-25000" dirty="0">
+                <a:solidFill>
+                  <a:srgbClr val="0F2240"/>
+                </a:solidFill>
+                <a:latin typeface="+mn-lt"/>
+              </a:rPr>
+              <a:t>0</a:t>
+            </a:r>
+            <a:r>
+              <a:rPr lang="en-GB" sz="2400" b="1" dirty="0">
+                <a:solidFill>
+                  <a:srgbClr val="0F2240"/>
+                </a:solidFill>
+                <a:latin typeface="+mn-lt"/>
+              </a:rPr>
+              <a:t xml:space="preserve"> (1 − s</a:t>
+            </a:r>
+            <a:r>
+              <a:rPr lang="en-GB" sz="2400" b="1" baseline="-25000" dirty="0">
+                <a:solidFill>
+                  <a:srgbClr val="0F2240"/>
+                </a:solidFill>
+                <a:latin typeface="+mn-lt"/>
+              </a:rPr>
+              <a:t>∞</a:t>
+            </a:r>
+            <a:r>
+              <a:rPr lang="en-GB" sz="2400" b="1" dirty="0">
+                <a:solidFill>
+                  <a:srgbClr val="0F2240"/>
+                </a:solidFill>
+                <a:latin typeface="+mn-lt"/>
+              </a:rPr>
+              <a:t xml:space="preserve"> − r</a:t>
+            </a:r>
+            <a:r>
+              <a:rPr lang="en-GB" sz="2400" b="1" baseline="-25000" dirty="0">
+                <a:solidFill>
+                  <a:srgbClr val="0F2240"/>
+                </a:solidFill>
+                <a:latin typeface="+mn-lt"/>
+              </a:rPr>
+              <a:t>0</a:t>
+            </a:r>
+            <a:r>
+              <a:rPr lang="en-GB" sz="2400" b="1" dirty="0">
+                <a:solidFill>
+                  <a:srgbClr val="0F2240"/>
+                </a:solidFill>
+                <a:latin typeface="+mn-lt"/>
+              </a:rPr>
+              <a:t xml:space="preserve"> − d</a:t>
+            </a:r>
+            <a:r>
+              <a:rPr lang="en-GB" sz="2400" b="1" baseline="-25000" dirty="0">
+                <a:solidFill>
+                  <a:srgbClr val="0F2240"/>
+                </a:solidFill>
+                <a:latin typeface="+mn-lt"/>
+              </a:rPr>
+              <a:t>0</a:t>
+            </a:r>
+            <a:r>
+              <a:rPr lang="en-GB" sz="2400" b="1" dirty="0">
+                <a:solidFill>
+                  <a:srgbClr val="0F2240"/>
+                </a:solidFill>
+                <a:latin typeface="+mn-lt"/>
+              </a:rPr>
+              <a:t>)</a:t>
+            </a:r>
+          </a:p>
+        </p:txBody>
+      </p:sp>
+      <p:sp>
+        <p:nvSpPr>
+          <p:cNvPr id="111" name="Stat 1"/>
+          <p:cNvSpPr txBox="1"/>
+          <p:nvPr/>
+        </p:nvSpPr>
+        <p:spPr>
+          <a:xfrm>
+            <a:off x="960120" y="3300000"/>
+            <a:ext cx="2240280" cy="1250000"/>
+          </a:xfrm>
+          <a:prstGeom prst="rect">
+            <a:avLst/>
+          </a:prstGeom>
+          <a:noFill/>
+        </p:spPr>
+        <p:txBody>
+          <a:bodyPr wrap="square" lIns="0" tIns="0" rIns="0" bIns="0" anchor="t">
+            <a:noAutofit/>
+          </a:bodyPr>
+          <a:lstStyle/>
+          <a:p>
+            <a:pPr algn="l">
+              <a:buNone/>
+            </a:pPr>
+            <a:r>
+              <a:rPr lang="en-GB" sz="5400" b="1" dirty="0">
+                <a:solidFill>
+                  <a:srgbClr val="1A56A0"/>
+                </a:solidFill>
+                <a:latin typeface="+mn-lt"/>
+              </a:rPr>
+              <a:t>80%</a:t>
+            </a:r>
+          </a:p>
+          <a:p>
+            <a:pPr algn="l">
+              <a:buNone/>
+            </a:pPr>
+            <a:r>
+              <a:rPr lang="en-GB" sz="1400" b="0" dirty="0">
+                <a:solidFill>
+                  <a:srgbClr val="475569"/>
+                </a:solidFill>
+                <a:latin typeface="+mn-lt"/>
+              </a:rPr>
+              <a:t>infected by the end (R</a:t>
+            </a:r>
+            <a:r>
+              <a:rPr lang="en-GB" sz="1400" b="0" baseline="-25000" dirty="0">
+                <a:solidFill>
+                  <a:srgbClr val="475569"/>
+                </a:solidFill>
+                <a:latin typeface="+mn-lt"/>
+              </a:rPr>
+              <a:t>0</a:t>
+            </a:r>
+            <a:r>
+              <a:rPr lang="en-GB" sz="1400" b="0" dirty="0">
+                <a:solidFill>
+                  <a:srgbClr val="475569"/>
+                </a:solidFill>
+                <a:latin typeface="+mn-lt"/>
+              </a:rPr>
+              <a:t xml:space="preserve"> = 2)</a:t>
+            </a:r>
+          </a:p>
+        </p:txBody>
+      </p:sp>
+      <p:sp>
+        <p:nvSpPr>
+          <p:cNvPr id="112" name="Stat 2"/>
+          <p:cNvSpPr txBox="1"/>
+          <p:nvPr/>
+        </p:nvSpPr>
+        <p:spPr>
+          <a:xfrm>
+            <a:off x="3383280" y="3300000"/>
+            <a:ext cx="2240280" cy="1250000"/>
+          </a:xfrm>
+          <a:prstGeom prst="rect">
+            <a:avLst/>
+          </a:prstGeom>
+          <a:noFill/>
+        </p:spPr>
+        <p:txBody>
+          <a:bodyPr wrap="square" lIns="0" tIns="0" rIns="0" bIns="0" anchor="t">
+            <a:noAutofit/>
+          </a:bodyPr>
+          <a:lstStyle/>
+          <a:p>
+            <a:pPr algn="l">
+              <a:buNone/>
+            </a:pPr>
+            <a:r>
+              <a:rPr lang="en-GB" sz="5400" b="1" dirty="0">
+                <a:solidFill>
+                  <a:srgbClr val="1A56A0"/>
+                </a:solidFill>
+                <a:latin typeface="+mn-lt"/>
+              </a:rPr>
+              <a:t>33%</a:t>
+            </a:r>
+          </a:p>
+          <a:p>
+            <a:pPr algn="l">
+              <a:buNone/>
+            </a:pPr>
+            <a:r>
+              <a:rPr lang="en-GB" sz="1400" b="0" dirty="0">
+                <a:solidFill>
+                  <a:srgbClr val="475569"/>
+                </a:solidFill>
+                <a:latin typeface="+mn-lt"/>
+              </a:rPr>
+              <a:t>die (41% of those infected)</a:t>
+            </a:r>
+          </a:p>
+        </p:txBody>
+      </p:sp>
+      <p:sp>
+        <p:nvSpPr>
+          <p:cNvPr id="113" name="Final size points"/>
+          <p:cNvSpPr txBox="1"/>
+          <p:nvPr/>
+        </p:nvSpPr>
+        <p:spPr>
+          <a:xfrm>
+            <a:off x="960120" y="4720000"/>
+            <a:ext cx="4663440" cy="1310000"/>
+          </a:xfrm>
+          <a:prstGeom prst="rect">
+            <a:avLst/>
+          </a:prstGeom>
+          <a:noFill/>
+        </p:spPr>
+        <p:txBody>
+          <a:bodyPr wrap="square" lIns="0" tIns="0" rIns="0" bIns="0" anchor="t">
+            <a:noAutofit/>
+          </a:bodyPr>
+          <a:lstStyle/>
+          <a:p>
+            <a:pPr algn="l" marL="228600" indent="-228600">
               <a:spcAft>
-                <a:spcPts val="800"/>
+                <a:spcPts val="1000"/>
               </a:spcAft>
-              <a:defRPr sz="1500" b="1">
+              <a:buClr>
+                <a:srgbClr val="1A56A0"/>
+              </a:buClr>
+              <a:buFont typeface="Arial"/>
+              <a:buChar char="•"/>
+            </a:pPr>
+            <a:r>
+              <a:rPr lang="en-GB" sz="1600" b="0" dirty="0">
+                <a:solidFill>
+                  <a:srgbClr val="1E293B"/>
+                </a:solidFill>
+                <a:latin typeface="+mn-lt"/>
+              </a:rPr>
+              <a:t>Formula and ODE agree to about 10</a:t>
+            </a:r>
+            <a:r>
+              <a:rPr lang="en-GB" sz="1600" b="0" baseline="30000" dirty="0">
+                <a:solidFill>
+                  <a:srgbClr val="1E293B"/>
+                </a:solidFill>
+                <a:latin typeface="+mn-lt"/>
+              </a:rPr>
+              <a:t>−12</a:t>
+            </a:r>
+            <a:r>
+              <a:rPr lang="en-GB" sz="1600" b="0" dirty="0">
+                <a:solidFill>
+                  <a:srgbClr val="1E293B"/>
+                </a:solidFill>
+                <a:latin typeface="+mn-lt"/>
+              </a:rPr>
+              <a:t xml:space="preserve"> for R</a:t>
+            </a:r>
+            <a:r>
+              <a:rPr lang="en-GB" sz="1600" b="0" baseline="-25000" dirty="0">
+                <a:solidFill>
+                  <a:srgbClr val="1E293B"/>
+                </a:solidFill>
+                <a:latin typeface="+mn-lt"/>
+              </a:rPr>
+              <a:t>0</a:t>
+            </a:r>
+            <a:r>
+              <a:rPr lang="en-GB" sz="1600" b="0" dirty="0">
+                <a:solidFill>
+                  <a:srgbClr val="1E293B"/>
+                </a:solidFill>
+                <a:latin typeface="+mn-lt"/>
+              </a:rPr>
+              <a:t xml:space="preserve"> from 0.8 to 3.5.</a:t>
+            </a:r>
+          </a:p>
+          <a:p>
+            <a:pPr algn="l" marL="228600" indent="-228600">
+              <a:buClr>
+                <a:srgbClr val="1A56A0"/>
+              </a:buClr>
+              <a:buFont typeface="Arial"/>
+              <a:buChar char="•"/>
+            </a:pPr>
+            <a:r>
+              <a:rPr lang="en-GB" sz="1600" b="0" dirty="0">
+                <a:solidFill>
+                  <a:srgbClr val="1E293B"/>
+                </a:solidFill>
+                <a:latin typeface="+mn-lt"/>
+              </a:rPr>
+              <a:t>The ODE must run until the epidemic ends (e + i &lt; 10</a:t>
+            </a:r>
+            <a:r>
+              <a:rPr lang="en-GB" sz="1600" b="0" baseline="30000" dirty="0">
+                <a:solidFill>
+                  <a:srgbClr val="1E293B"/>
+                </a:solidFill>
+                <a:latin typeface="+mn-lt"/>
+              </a:rPr>
+              <a:t>−13</a:t>
+            </a:r>
+            <a:r>
+              <a:rPr lang="en-GB" sz="1600" b="0" dirty="0">
+                <a:solidFill>
+                  <a:srgbClr val="1E293B"/>
+                </a:solidFill>
+                <a:latin typeface="+mn-lt"/>
+              </a:rPr>
+              <a:t>); stopping at day 250 gave errors up to 0.6%.</a:t>
+            </a:r>
+          </a:p>
+        </p:txBody>
+      </p:sp>
+      <p:sp>
+        <p:nvSpPr>
+          <p:cNvPr id="114" name="Heading"/>
+          <p:cNvSpPr txBox="1"/>
+          <p:nvPr/>
+        </p:nvSpPr>
+        <p:spPr>
+          <a:xfrm>
+            <a:off x="6446520" y="1828800"/>
+            <a:ext cx="4754880" cy="420000"/>
+          </a:xfrm>
+          <a:prstGeom prst="rect">
+            <a:avLst/>
+          </a:prstGeom>
+          <a:noFill/>
+        </p:spPr>
+        <p:txBody>
+          <a:bodyPr wrap="square" lIns="0" tIns="0" rIns="0" bIns="0" anchor="t">
+            <a:noAutofit/>
+          </a:bodyPr>
+          <a:lstStyle/>
+          <a:p>
+            <a:pPr algn="l">
+              <a:buNone/>
+            </a:pPr>
+            <a:r>
+              <a:rPr lang="en-GB" sz="2000" b="1" dirty="0">
                 <a:solidFill>
                   <a:srgbClr val="0F2240"/>
                 </a:solidFill>
-              </a:defRPr>
-            </a:pPr>
-            <a:r>
-              <a:t>Global Sensitivity (Latin Hypercube + PRCC, n = 1000)</a:t>
-            </a:r>
-          </a:p>
-          <a:p>
-            <a:pPr>
+                <a:latin typeface="+mn-lt"/>
+              </a:rPr>
+              <a:t>Sensitivity: Latin hypercube + PRCC</a:t>
+            </a:r>
+          </a:p>
+        </p:txBody>
+      </p:sp>
+      <p:graphicFrame>
+        <p:nvGraphicFramePr>
+          <p:cNvPr id="115" name="PRCC table"/>
+          <p:cNvGraphicFramePr>
+            <a:graphicFrameLocks noGrp="1"/>
+          </p:cNvGraphicFramePr>
+          <p:nvPr/>
+        </p:nvGraphicFramePr>
+        <p:xfrm>
+          <a:off x="6446520" y="2330000"/>
+          <a:ext cx="4754880" cy="2000000"/>
+        </p:xfrm>
+        <a:graphic>
+          <a:graphicData uri="http://schemas.openxmlformats.org/drawingml/2006/table">
+            <a:tbl>
+              <a:tblPr firstRow="1"/>
+              <a:tblGrid>
+                <a:gridCol w="674880"/>
+                <a:gridCol w="1020000"/>
+                <a:gridCol w="1020000"/>
+                <a:gridCol w="1020000"/>
+                <a:gridCol w="1020000"/>
+              </a:tblGrid>
+              <a:tr h="400000">
+                <a:tc>
+                  <a:txBody>
+                    <a:bodyPr/>
+                    <a:lstStyle/>
+                    <a:p>
+                      <a:pPr algn="ctr">
+                        <a:buNone/>
+                      </a:pPr>
+                    </a:p>
+                  </a:txBody>
+                  <a:tcPr marL="64008" marR="64008" marT="27432" marB="27432" anchor="ctr">
+                    <a:lnL w="9525">
+                      <a:solidFill>
+                        <a:srgbClr val="CBD5E1"/>
+                      </a:solidFill>
+                    </a:lnL>
+                    <a:lnR w="9525">
+                      <a:solidFill>
+                        <a:srgbClr val="CBD5E1"/>
+                      </a:solidFill>
+                    </a:lnR>
+                    <a:lnT w="9525">
+                      <a:solidFill>
+                        <a:srgbClr val="CBD5E1"/>
+                      </a:solidFill>
+                    </a:lnT>
+                    <a:lnB w="9525">
+                      <a:solidFill>
+                        <a:srgbClr val="CBD5E1"/>
+                      </a:solidFill>
+                    </a:lnB>
+                    <a:solidFill>
+                      <a:srgbClr val="0F2240"/>
+                    </a:solidFill>
+                  </a:tcPr>
+                </a:tc>
+                <a:tc>
+                  <a:txBody>
+                    <a:bodyPr/>
+                    <a:lstStyle/>
+                    <a:p>
+                      <a:pPr algn="ctr">
+                        <a:buNone/>
+                      </a:pPr>
+                      <a:r>
+                        <a:rPr lang="en-GB" sz="1500" b="1" dirty="0">
+                          <a:solidFill>
+                            <a:srgbClr val="FFFFFF"/>
+                          </a:solidFill>
+                          <a:latin typeface="+mn-lt"/>
+                        </a:rPr>
+                        <a:t>peak</a:t>
+                      </a:r>
+                    </a:p>
+                  </a:txBody>
+                  <a:tcPr marL="64008" marR="64008" marT="27432" marB="27432" anchor="ctr">
+                    <a:lnL w="9525">
+                      <a:solidFill>
+                        <a:srgbClr val="CBD5E1"/>
+                      </a:solidFill>
+                    </a:lnL>
+                    <a:lnR w="9525">
+                      <a:solidFill>
+                        <a:srgbClr val="CBD5E1"/>
+                      </a:solidFill>
+                    </a:lnR>
+                    <a:lnT w="9525">
+                      <a:solidFill>
+                        <a:srgbClr val="CBD5E1"/>
+                      </a:solidFill>
+                    </a:lnT>
+                    <a:lnB w="9525">
+                      <a:solidFill>
+                        <a:srgbClr val="CBD5E1"/>
+                      </a:solidFill>
+                    </a:lnB>
+                    <a:solidFill>
+                      <a:srgbClr val="0F2240"/>
+                    </a:solidFill>
+                  </a:tcPr>
+                </a:tc>
+                <a:tc>
+                  <a:txBody>
+                    <a:bodyPr/>
+                    <a:lstStyle/>
+                    <a:p>
+                      <a:pPr algn="ctr">
+                        <a:buNone/>
+                      </a:pPr>
+                      <a:r>
+                        <a:rPr lang="en-GB" sz="1500" b="1" dirty="0">
+                          <a:solidFill>
+                            <a:srgbClr val="FFFFFF"/>
+                          </a:solidFill>
+                          <a:latin typeface="+mn-lt"/>
+                        </a:rPr>
+                        <a:t>peak day</a:t>
+                      </a:r>
+                    </a:p>
+                  </a:txBody>
+                  <a:tcPr marL="64008" marR="64008" marT="27432" marB="27432" anchor="ctr">
+                    <a:lnL w="9525">
+                      <a:solidFill>
+                        <a:srgbClr val="CBD5E1"/>
+                      </a:solidFill>
+                    </a:lnL>
+                    <a:lnR w="9525">
+                      <a:solidFill>
+                        <a:srgbClr val="CBD5E1"/>
+                      </a:solidFill>
+                    </a:lnR>
+                    <a:lnT w="9525">
+                      <a:solidFill>
+                        <a:srgbClr val="CBD5E1"/>
+                      </a:solidFill>
+                    </a:lnT>
+                    <a:lnB w="9525">
+                      <a:solidFill>
+                        <a:srgbClr val="CBD5E1"/>
+                      </a:solidFill>
+                    </a:lnB>
+                    <a:solidFill>
+                      <a:srgbClr val="0F2240"/>
+                    </a:solidFill>
+                  </a:tcPr>
+                </a:tc>
+                <a:tc>
+                  <a:txBody>
+                    <a:bodyPr/>
+                    <a:lstStyle/>
+                    <a:p>
+                      <a:pPr algn="ctr">
+                        <a:buNone/>
+                      </a:pPr>
+                      <a:r>
+                        <a:rPr lang="en-GB" sz="1500" b="1" dirty="0">
+                          <a:solidFill>
+                            <a:srgbClr val="FFFFFF"/>
+                          </a:solidFill>
+                          <a:latin typeface="+mn-lt"/>
+                        </a:rPr>
+                        <a:t>attack rate</a:t>
+                      </a:r>
+                    </a:p>
+                  </a:txBody>
+                  <a:tcPr marL="64008" marR="64008" marT="27432" marB="27432" anchor="ctr">
+                    <a:lnL w="9525">
+                      <a:solidFill>
+                        <a:srgbClr val="CBD5E1"/>
+                      </a:solidFill>
+                    </a:lnL>
+                    <a:lnR w="9525">
+                      <a:solidFill>
+                        <a:srgbClr val="CBD5E1"/>
+                      </a:solidFill>
+                    </a:lnR>
+                    <a:lnT w="9525">
+                      <a:solidFill>
+                        <a:srgbClr val="CBD5E1"/>
+                      </a:solidFill>
+                    </a:lnT>
+                    <a:lnB w="9525">
+                      <a:solidFill>
+                        <a:srgbClr val="CBD5E1"/>
+                      </a:solidFill>
+                    </a:lnB>
+                    <a:solidFill>
+                      <a:srgbClr val="0F2240"/>
+                    </a:solidFill>
+                  </a:tcPr>
+                </a:tc>
+                <a:tc>
+                  <a:txBody>
+                    <a:bodyPr/>
+                    <a:lstStyle/>
+                    <a:p>
+                      <a:pPr algn="ctr">
+                        <a:buNone/>
+                      </a:pPr>
+                      <a:r>
+                        <a:rPr lang="en-GB" sz="1500" b="1" dirty="0">
+                          <a:solidFill>
+                            <a:srgbClr val="FFFFFF"/>
+                          </a:solidFill>
+                          <a:latin typeface="+mn-lt"/>
+                        </a:rPr>
+                        <a:t>deaths</a:t>
+                      </a:r>
+                    </a:p>
+                  </a:txBody>
+                  <a:tcPr marL="64008" marR="64008" marT="27432" marB="27432" anchor="ctr">
+                    <a:lnL w="9525">
+                      <a:solidFill>
+                        <a:srgbClr val="CBD5E1"/>
+                      </a:solidFill>
+                    </a:lnL>
+                    <a:lnR w="9525">
+                      <a:solidFill>
+                        <a:srgbClr val="CBD5E1"/>
+                      </a:solidFill>
+                    </a:lnR>
+                    <a:lnT w="9525">
+                      <a:solidFill>
+                        <a:srgbClr val="CBD5E1"/>
+                      </a:solidFill>
+                    </a:lnT>
+                    <a:lnB w="9525">
+                      <a:solidFill>
+                        <a:srgbClr val="CBD5E1"/>
+                      </a:solidFill>
+                    </a:lnB>
+                    <a:solidFill>
+                      <a:srgbClr val="0F2240"/>
+                    </a:solidFill>
+                  </a:tcPr>
+                </a:tc>
+              </a:tr>
+              <a:tr h="400000">
+                <a:tc>
+                  <a:txBody>
+                    <a:bodyPr/>
+                    <a:lstStyle/>
+                    <a:p>
+                      <a:pPr algn="ctr">
+                        <a:buNone/>
+                      </a:pPr>
+                      <a:r>
+                        <a:rPr lang="en-GB" sz="1500" b="1" dirty="0">
+                          <a:solidFill>
+                            <a:srgbClr val="1E293B"/>
+                          </a:solidFill>
+                          <a:latin typeface="+mn-lt"/>
+                        </a:rPr>
+                        <a:t>β</a:t>
+                      </a:r>
+                    </a:p>
+                  </a:txBody>
+                  <a:tcPr marL="64008" marR="64008" marT="27432" marB="27432" anchor="ctr">
+                    <a:lnL w="9525">
+                      <a:solidFill>
+                        <a:srgbClr val="CBD5E1"/>
+                      </a:solidFill>
+                    </a:lnL>
+                    <a:lnR w="9525">
+                      <a:solidFill>
+                        <a:srgbClr val="CBD5E1"/>
+                      </a:solidFill>
+                    </a:lnR>
+                    <a:lnT w="9525">
+                      <a:solidFill>
+                        <a:srgbClr val="CBD5E1"/>
+                      </a:solidFill>
+                    </a:lnT>
+                    <a:lnB w="9525">
+                      <a:solidFill>
+                        <a:srgbClr val="CBD5E1"/>
+                      </a:solidFill>
+                    </a:lnB>
+                    <a:solidFill>
+                      <a:srgbClr val="FFFFFF"/>
+                    </a:solidFill>
+                  </a:tcPr>
+                </a:tc>
+                <a:tc>
+                  <a:txBody>
+                    <a:bodyPr/>
+                    <a:lstStyle/>
+                    <a:p>
+                      <a:pPr algn="ctr">
+                        <a:buNone/>
+                      </a:pPr>
+                      <a:r>
+                        <a:rPr lang="en-GB" sz="1500" b="0" dirty="0">
+                          <a:solidFill>
+                            <a:srgbClr val="1E3A8A"/>
+                          </a:solidFill>
+                          <a:latin typeface="+mn-lt"/>
+                        </a:rPr>
+                        <a:t>+0.96</a:t>
+                      </a:r>
+                    </a:p>
+                  </a:txBody>
+                  <a:tcPr marL="64008" marR="64008" marT="27432" marB="27432" anchor="ctr">
+                    <a:lnL w="9525">
+                      <a:solidFill>
+                        <a:srgbClr val="CBD5E1"/>
+                      </a:solidFill>
+                    </a:lnL>
+                    <a:lnR w="9525">
+                      <a:solidFill>
+                        <a:srgbClr val="CBD5E1"/>
+                      </a:solidFill>
+                    </a:lnR>
+                    <a:lnT w="9525">
+                      <a:solidFill>
+                        <a:srgbClr val="CBD5E1"/>
+                      </a:solidFill>
+                    </a:lnT>
+                    <a:lnB w="9525">
+                      <a:solidFill>
+                        <a:srgbClr val="CBD5E1"/>
+                      </a:solidFill>
+                    </a:lnB>
+                    <a:solidFill>
+                      <a:srgbClr val="DBEAFE"/>
+                    </a:solidFill>
+                  </a:tcPr>
+                </a:tc>
+                <a:tc>
+                  <a:txBody>
+                    <a:bodyPr/>
+                    <a:lstStyle/>
+                    <a:p>
+                      <a:pPr algn="ctr">
+                        <a:buNone/>
+                      </a:pPr>
+                      <a:r>
+                        <a:rPr lang="en-GB" sz="1500" b="0" dirty="0">
+                          <a:solidFill>
+                            <a:srgbClr val="991B1B"/>
+                          </a:solidFill>
+                          <a:latin typeface="+mn-lt"/>
+                        </a:rPr>
+                        <a:t>−0.96</a:t>
+                      </a:r>
+                    </a:p>
+                  </a:txBody>
+                  <a:tcPr marL="64008" marR="64008" marT="27432" marB="27432" anchor="ctr">
+                    <a:lnL w="9525">
+                      <a:solidFill>
+                        <a:srgbClr val="CBD5E1"/>
+                      </a:solidFill>
+                    </a:lnL>
+                    <a:lnR w="9525">
+                      <a:solidFill>
+                        <a:srgbClr val="CBD5E1"/>
+                      </a:solidFill>
+                    </a:lnR>
+                    <a:lnT w="9525">
+                      <a:solidFill>
+                        <a:srgbClr val="CBD5E1"/>
+                      </a:solidFill>
+                    </a:lnT>
+                    <a:lnB w="9525">
+                      <a:solidFill>
+                        <a:srgbClr val="CBD5E1"/>
+                      </a:solidFill>
+                    </a:lnB>
+                    <a:solidFill>
+                      <a:srgbClr val="FDE2E2"/>
+                    </a:solidFill>
+                  </a:tcPr>
+                </a:tc>
+                <a:tc>
+                  <a:txBody>
+                    <a:bodyPr/>
+                    <a:lstStyle/>
+                    <a:p>
+                      <a:pPr algn="ctr">
+                        <a:buNone/>
+                      </a:pPr>
+                      <a:r>
+                        <a:rPr lang="en-GB" sz="1500" b="0" dirty="0">
+                          <a:solidFill>
+                            <a:srgbClr val="1E3A8A"/>
+                          </a:solidFill>
+                          <a:latin typeface="+mn-lt"/>
+                        </a:rPr>
+                        <a:t>+0.98</a:t>
+                      </a:r>
+                    </a:p>
+                  </a:txBody>
+                  <a:tcPr marL="64008" marR="64008" marT="27432" marB="27432" anchor="ctr">
+                    <a:lnL w="9525">
+                      <a:solidFill>
+                        <a:srgbClr val="CBD5E1"/>
+                      </a:solidFill>
+                    </a:lnL>
+                    <a:lnR w="9525">
+                      <a:solidFill>
+                        <a:srgbClr val="CBD5E1"/>
+                      </a:solidFill>
+                    </a:lnR>
+                    <a:lnT w="9525">
+                      <a:solidFill>
+                        <a:srgbClr val="CBD5E1"/>
+                      </a:solidFill>
+                    </a:lnT>
+                    <a:lnB w="9525">
+                      <a:solidFill>
+                        <a:srgbClr val="CBD5E1"/>
+                      </a:solidFill>
+                    </a:lnB>
+                    <a:solidFill>
+                      <a:srgbClr val="DBEAFE"/>
+                    </a:solidFill>
+                  </a:tcPr>
+                </a:tc>
+                <a:tc>
+                  <a:txBody>
+                    <a:bodyPr/>
+                    <a:lstStyle/>
+                    <a:p>
+                      <a:pPr algn="ctr">
+                        <a:buNone/>
+                      </a:pPr>
+                      <a:r>
+                        <a:rPr lang="en-GB" sz="1500" b="0" dirty="0">
+                          <a:solidFill>
+                            <a:srgbClr val="1E3A8A"/>
+                          </a:solidFill>
+                          <a:latin typeface="+mn-lt"/>
+                        </a:rPr>
+                        <a:t>+0.90</a:t>
+                      </a:r>
+                    </a:p>
+                  </a:txBody>
+                  <a:tcPr marL="64008" marR="64008" marT="27432" marB="27432" anchor="ctr">
+                    <a:lnL w="9525">
+                      <a:solidFill>
+                        <a:srgbClr val="CBD5E1"/>
+                      </a:solidFill>
+                    </a:lnL>
+                    <a:lnR w="9525">
+                      <a:solidFill>
+                        <a:srgbClr val="CBD5E1"/>
+                      </a:solidFill>
+                    </a:lnR>
+                    <a:lnT w="9525">
+                      <a:solidFill>
+                        <a:srgbClr val="CBD5E1"/>
+                      </a:solidFill>
+                    </a:lnT>
+                    <a:lnB w="9525">
+                      <a:solidFill>
+                        <a:srgbClr val="CBD5E1"/>
+                      </a:solidFill>
+                    </a:lnB>
+                    <a:solidFill>
+                      <a:srgbClr val="DBEAFE"/>
+                    </a:solidFill>
+                  </a:tcPr>
+                </a:tc>
+              </a:tr>
+              <a:tr h="400000">
+                <a:tc>
+                  <a:txBody>
+                    <a:bodyPr/>
+                    <a:lstStyle/>
+                    <a:p>
+                      <a:pPr algn="ctr">
+                        <a:buNone/>
+                      </a:pPr>
+                      <a:r>
+                        <a:rPr lang="en-GB" sz="1500" b="1" dirty="0">
+                          <a:solidFill>
+                            <a:srgbClr val="1E293B"/>
+                          </a:solidFill>
+                          <a:latin typeface="+mn-lt"/>
+                        </a:rPr>
+                        <a:t>σ</a:t>
+                      </a:r>
+                    </a:p>
+                  </a:txBody>
+                  <a:tcPr marL="64008" marR="64008" marT="27432" marB="27432" anchor="ctr">
+                    <a:lnL w="9525">
+                      <a:solidFill>
+                        <a:srgbClr val="CBD5E1"/>
+                      </a:solidFill>
+                    </a:lnL>
+                    <a:lnR w="9525">
+                      <a:solidFill>
+                        <a:srgbClr val="CBD5E1"/>
+                      </a:solidFill>
+                    </a:lnR>
+                    <a:lnT w="9525">
+                      <a:solidFill>
+                        <a:srgbClr val="CBD5E1"/>
+                      </a:solidFill>
+                    </a:lnT>
+                    <a:lnB w="9525">
+                      <a:solidFill>
+                        <a:srgbClr val="CBD5E1"/>
+                      </a:solidFill>
+                    </a:lnB>
+                    <a:solidFill>
+                      <a:srgbClr val="FFFFFF"/>
+                    </a:solidFill>
+                  </a:tcPr>
+                </a:tc>
+                <a:tc>
+                  <a:txBody>
+                    <a:bodyPr/>
+                    <a:lstStyle/>
+                    <a:p>
+                      <a:pPr algn="ctr">
+                        <a:buNone/>
+                      </a:pPr>
+                      <a:r>
+                        <a:rPr lang="en-GB" sz="1500" b="0" dirty="0">
+                          <a:solidFill>
+                            <a:srgbClr val="1E3A8A"/>
+                          </a:solidFill>
+                          <a:latin typeface="+mn-lt"/>
+                        </a:rPr>
+                        <a:t>+0.68</a:t>
+                      </a:r>
+                    </a:p>
+                  </a:txBody>
+                  <a:tcPr marL="64008" marR="64008" marT="27432" marB="27432" anchor="ctr">
+                    <a:lnL w="9525">
+                      <a:solidFill>
+                        <a:srgbClr val="CBD5E1"/>
+                      </a:solidFill>
+                    </a:lnL>
+                    <a:lnR w="9525">
+                      <a:solidFill>
+                        <a:srgbClr val="CBD5E1"/>
+                      </a:solidFill>
+                    </a:lnR>
+                    <a:lnT w="9525">
+                      <a:solidFill>
+                        <a:srgbClr val="CBD5E1"/>
+                      </a:solidFill>
+                    </a:lnT>
+                    <a:lnB w="9525">
+                      <a:solidFill>
+                        <a:srgbClr val="CBD5E1"/>
+                      </a:solidFill>
+                    </a:lnB>
+                    <a:solidFill>
+                      <a:srgbClr val="DBEAFE"/>
+                    </a:solidFill>
+                  </a:tcPr>
+                </a:tc>
+                <a:tc>
+                  <a:txBody>
+                    <a:bodyPr/>
+                    <a:lstStyle/>
+                    <a:p>
+                      <a:pPr algn="ctr">
+                        <a:buNone/>
+                      </a:pPr>
+                      <a:r>
+                        <a:rPr lang="en-GB" sz="1500" b="0" dirty="0">
+                          <a:solidFill>
+                            <a:srgbClr val="991B1B"/>
+                          </a:solidFill>
+                          <a:latin typeface="+mn-lt"/>
+                        </a:rPr>
+                        <a:t>−0.83</a:t>
+                      </a:r>
+                    </a:p>
+                  </a:txBody>
+                  <a:tcPr marL="64008" marR="64008" marT="27432" marB="27432" anchor="ctr">
+                    <a:lnL w="9525">
+                      <a:solidFill>
+                        <a:srgbClr val="CBD5E1"/>
+                      </a:solidFill>
+                    </a:lnL>
+                    <a:lnR w="9525">
+                      <a:solidFill>
+                        <a:srgbClr val="CBD5E1"/>
+                      </a:solidFill>
+                    </a:lnR>
+                    <a:lnT w="9525">
+                      <a:solidFill>
+                        <a:srgbClr val="CBD5E1"/>
+                      </a:solidFill>
+                    </a:lnT>
+                    <a:lnB w="9525">
+                      <a:solidFill>
+                        <a:srgbClr val="CBD5E1"/>
+                      </a:solidFill>
+                    </a:lnB>
+                    <a:solidFill>
+                      <a:srgbClr val="FDE2E2"/>
+                    </a:solidFill>
+                  </a:tcPr>
+                </a:tc>
+                <a:tc>
+                  <a:txBody>
+                    <a:bodyPr/>
+                    <a:lstStyle/>
+                    <a:p>
+                      <a:pPr algn="ctr">
+                        <a:buNone/>
+                      </a:pPr>
+                      <a:r>
+                        <a:rPr lang="en-GB" sz="1500" b="0" dirty="0">
+                          <a:solidFill>
+                            <a:srgbClr val="64748B"/>
+                          </a:solidFill>
+                          <a:latin typeface="+mn-lt"/>
+                        </a:rPr>
+                        <a:t>≈ 0 (n.s.)</a:t>
+                      </a:r>
+                    </a:p>
+                  </a:txBody>
+                  <a:tcPr marL="64008" marR="64008" marT="27432" marB="27432" anchor="ctr">
+                    <a:lnL w="9525">
+                      <a:solidFill>
+                        <a:srgbClr val="CBD5E1"/>
+                      </a:solidFill>
+                    </a:lnL>
+                    <a:lnR w="9525">
+                      <a:solidFill>
+                        <a:srgbClr val="CBD5E1"/>
+                      </a:solidFill>
+                    </a:lnR>
+                    <a:lnT w="9525">
+                      <a:solidFill>
+                        <a:srgbClr val="CBD5E1"/>
+                      </a:solidFill>
+                    </a:lnT>
+                    <a:lnB w="9525">
+                      <a:solidFill>
+                        <a:srgbClr val="CBD5E1"/>
+                      </a:solidFill>
+                    </a:lnB>
+                    <a:solidFill>
+                      <a:srgbClr val="F1F5F9"/>
+                    </a:solidFill>
+                  </a:tcPr>
+                </a:tc>
+                <a:tc>
+                  <a:txBody>
+                    <a:bodyPr/>
+                    <a:lstStyle/>
+                    <a:p>
+                      <a:pPr algn="ctr">
+                        <a:buNone/>
+                      </a:pPr>
+                      <a:r>
+                        <a:rPr lang="en-GB" sz="1500" b="0" dirty="0">
+                          <a:solidFill>
+                            <a:srgbClr val="64748B"/>
+                          </a:solidFill>
+                          <a:latin typeface="+mn-lt"/>
+                        </a:rPr>
+                        <a:t>≈ 0 (n.s.)</a:t>
+                      </a:r>
+                    </a:p>
+                  </a:txBody>
+                  <a:tcPr marL="64008" marR="64008" marT="27432" marB="27432" anchor="ctr">
+                    <a:lnL w="9525">
+                      <a:solidFill>
+                        <a:srgbClr val="CBD5E1"/>
+                      </a:solidFill>
+                    </a:lnL>
+                    <a:lnR w="9525">
+                      <a:solidFill>
+                        <a:srgbClr val="CBD5E1"/>
+                      </a:solidFill>
+                    </a:lnR>
+                    <a:lnT w="9525">
+                      <a:solidFill>
+                        <a:srgbClr val="CBD5E1"/>
+                      </a:solidFill>
+                    </a:lnT>
+                    <a:lnB w="9525">
+                      <a:solidFill>
+                        <a:srgbClr val="CBD5E1"/>
+                      </a:solidFill>
+                    </a:lnB>
+                    <a:solidFill>
+                      <a:srgbClr val="F1F5F9"/>
+                    </a:solidFill>
+                  </a:tcPr>
+                </a:tc>
+              </a:tr>
+              <a:tr h="400000">
+                <a:tc>
+                  <a:txBody>
+                    <a:bodyPr/>
+                    <a:lstStyle/>
+                    <a:p>
+                      <a:pPr algn="ctr">
+                        <a:buNone/>
+                      </a:pPr>
+                      <a:r>
+                        <a:rPr lang="en-GB" sz="1500" b="1" dirty="0">
+                          <a:solidFill>
+                            <a:srgbClr val="1E293B"/>
+                          </a:solidFill>
+                          <a:latin typeface="+mn-lt"/>
+                        </a:rPr>
+                        <a:t>γ</a:t>
+                      </a:r>
+                    </a:p>
+                  </a:txBody>
+                  <a:tcPr marL="64008" marR="64008" marT="27432" marB="27432" anchor="ctr">
+                    <a:lnL w="9525">
+                      <a:solidFill>
+                        <a:srgbClr val="CBD5E1"/>
+                      </a:solidFill>
+                    </a:lnL>
+                    <a:lnR w="9525">
+                      <a:solidFill>
+                        <a:srgbClr val="CBD5E1"/>
+                      </a:solidFill>
+                    </a:lnR>
+                    <a:lnT w="9525">
+                      <a:solidFill>
+                        <a:srgbClr val="CBD5E1"/>
+                      </a:solidFill>
+                    </a:lnT>
+                    <a:lnB w="9525">
+                      <a:solidFill>
+                        <a:srgbClr val="CBD5E1"/>
+                      </a:solidFill>
+                    </a:lnB>
+                    <a:solidFill>
+                      <a:srgbClr val="FFFFFF"/>
+                    </a:solidFill>
+                  </a:tcPr>
+                </a:tc>
+                <a:tc>
+                  <a:txBody>
+                    <a:bodyPr/>
+                    <a:lstStyle/>
+                    <a:p>
+                      <a:pPr algn="ctr">
+                        <a:buNone/>
+                      </a:pPr>
+                      <a:r>
+                        <a:rPr lang="en-GB" sz="1500" b="0" dirty="0">
+                          <a:solidFill>
+                            <a:srgbClr val="991B1B"/>
+                          </a:solidFill>
+                          <a:latin typeface="+mn-lt"/>
+                        </a:rPr>
+                        <a:t>−0.94</a:t>
+                      </a:r>
+                    </a:p>
+                  </a:txBody>
+                  <a:tcPr marL="64008" marR="64008" marT="27432" marB="27432" anchor="ctr">
+                    <a:lnL w="9525">
+                      <a:solidFill>
+                        <a:srgbClr val="CBD5E1"/>
+                      </a:solidFill>
+                    </a:lnL>
+                    <a:lnR w="9525">
+                      <a:solidFill>
+                        <a:srgbClr val="CBD5E1"/>
+                      </a:solidFill>
+                    </a:lnR>
+                    <a:lnT w="9525">
+                      <a:solidFill>
+                        <a:srgbClr val="CBD5E1"/>
+                      </a:solidFill>
+                    </a:lnT>
+                    <a:lnB w="9525">
+                      <a:solidFill>
+                        <a:srgbClr val="CBD5E1"/>
+                      </a:solidFill>
+                    </a:lnB>
+                    <a:solidFill>
+                      <a:srgbClr val="FDE2E2"/>
+                    </a:solidFill>
+                  </a:tcPr>
+                </a:tc>
+                <a:tc>
+                  <a:txBody>
+                    <a:bodyPr/>
+                    <a:lstStyle/>
+                    <a:p>
+                      <a:pPr algn="ctr">
+                        <a:buNone/>
+                      </a:pPr>
+                      <a:r>
+                        <a:rPr lang="en-GB" sz="1500" b="0" dirty="0">
+                          <a:solidFill>
+                            <a:srgbClr val="1E3A8A"/>
+                          </a:solidFill>
+                          <a:latin typeface="+mn-lt"/>
+                        </a:rPr>
+                        <a:t>+0.75</a:t>
+                      </a:r>
+                    </a:p>
+                  </a:txBody>
+                  <a:tcPr marL="64008" marR="64008" marT="27432" marB="27432" anchor="ctr">
+                    <a:lnL w="9525">
+                      <a:solidFill>
+                        <a:srgbClr val="CBD5E1"/>
+                      </a:solidFill>
+                    </a:lnL>
+                    <a:lnR w="9525">
+                      <a:solidFill>
+                        <a:srgbClr val="CBD5E1"/>
+                      </a:solidFill>
+                    </a:lnR>
+                    <a:lnT w="9525">
+                      <a:solidFill>
+                        <a:srgbClr val="CBD5E1"/>
+                      </a:solidFill>
+                    </a:lnT>
+                    <a:lnB w="9525">
+                      <a:solidFill>
+                        <a:srgbClr val="CBD5E1"/>
+                      </a:solidFill>
+                    </a:lnB>
+                    <a:solidFill>
+                      <a:srgbClr val="DBEAFE"/>
+                    </a:solidFill>
+                  </a:tcPr>
+                </a:tc>
+                <a:tc>
+                  <a:txBody>
+                    <a:bodyPr/>
+                    <a:lstStyle/>
+                    <a:p>
+                      <a:pPr algn="ctr">
+                        <a:buNone/>
+                      </a:pPr>
+                      <a:r>
+                        <a:rPr lang="en-GB" sz="1500" b="0" dirty="0">
+                          <a:solidFill>
+                            <a:srgbClr val="991B1B"/>
+                          </a:solidFill>
+                          <a:latin typeface="+mn-lt"/>
+                        </a:rPr>
+                        <a:t>−0.95</a:t>
+                      </a:r>
+                    </a:p>
+                  </a:txBody>
+                  <a:tcPr marL="64008" marR="64008" marT="27432" marB="27432" anchor="ctr">
+                    <a:lnL w="9525">
+                      <a:solidFill>
+                        <a:srgbClr val="CBD5E1"/>
+                      </a:solidFill>
+                    </a:lnL>
+                    <a:lnR w="9525">
+                      <a:solidFill>
+                        <a:srgbClr val="CBD5E1"/>
+                      </a:solidFill>
+                    </a:lnR>
+                    <a:lnT w="9525">
+                      <a:solidFill>
+                        <a:srgbClr val="CBD5E1"/>
+                      </a:solidFill>
+                    </a:lnT>
+                    <a:lnB w="9525">
+                      <a:solidFill>
+                        <a:srgbClr val="CBD5E1"/>
+                      </a:solidFill>
+                    </a:lnB>
+                    <a:solidFill>
+                      <a:srgbClr val="FDE2E2"/>
+                    </a:solidFill>
+                  </a:tcPr>
+                </a:tc>
+                <a:tc>
+                  <a:txBody>
+                    <a:bodyPr/>
+                    <a:lstStyle/>
+                    <a:p>
+                      <a:pPr algn="ctr">
+                        <a:buNone/>
+                      </a:pPr>
+                      <a:r>
+                        <a:rPr lang="en-GB" sz="1500" b="0" dirty="0">
+                          <a:solidFill>
+                            <a:srgbClr val="991B1B"/>
+                          </a:solidFill>
+                          <a:latin typeface="+mn-lt"/>
+                        </a:rPr>
+                        <a:t>−0.95</a:t>
+                      </a:r>
+                    </a:p>
+                  </a:txBody>
+                  <a:tcPr marL="64008" marR="64008" marT="27432" marB="27432" anchor="ctr">
+                    <a:lnL w="9525">
+                      <a:solidFill>
+                        <a:srgbClr val="CBD5E1"/>
+                      </a:solidFill>
+                    </a:lnL>
+                    <a:lnR w="9525">
+                      <a:solidFill>
+                        <a:srgbClr val="CBD5E1"/>
+                      </a:solidFill>
+                    </a:lnR>
+                    <a:lnT w="9525">
+                      <a:solidFill>
+                        <a:srgbClr val="CBD5E1"/>
+                      </a:solidFill>
+                    </a:lnT>
+                    <a:lnB w="9525">
+                      <a:solidFill>
+                        <a:srgbClr val="CBD5E1"/>
+                      </a:solidFill>
+                    </a:lnB>
+                    <a:solidFill>
+                      <a:srgbClr val="FDE2E2"/>
+                    </a:solidFill>
+                  </a:tcPr>
+                </a:tc>
+              </a:tr>
+              <a:tr h="400000">
+                <a:tc>
+                  <a:txBody>
+                    <a:bodyPr/>
+                    <a:lstStyle/>
+                    <a:p>
+                      <a:pPr algn="ctr">
+                        <a:buNone/>
+                      </a:pPr>
+                      <a:r>
+                        <a:rPr lang="en-GB" sz="1500" b="1" dirty="0">
+                          <a:solidFill>
+                            <a:srgbClr val="1E293B"/>
+                          </a:solidFill>
+                          <a:latin typeface="+mn-lt"/>
+                        </a:rPr>
+                        <a:t>μ</a:t>
+                      </a:r>
+                    </a:p>
+                  </a:txBody>
+                  <a:tcPr marL="64008" marR="64008" marT="27432" marB="27432" anchor="ctr">
+                    <a:lnL w="9525">
+                      <a:solidFill>
+                        <a:srgbClr val="CBD5E1"/>
+                      </a:solidFill>
+                    </a:lnL>
+                    <a:lnR w="9525">
+                      <a:solidFill>
+                        <a:srgbClr val="CBD5E1"/>
+                      </a:solidFill>
+                    </a:lnR>
+                    <a:lnT w="9525">
+                      <a:solidFill>
+                        <a:srgbClr val="CBD5E1"/>
+                      </a:solidFill>
+                    </a:lnT>
+                    <a:lnB w="9525">
+                      <a:solidFill>
+                        <a:srgbClr val="CBD5E1"/>
+                      </a:solidFill>
+                    </a:lnB>
+                    <a:solidFill>
+                      <a:srgbClr val="FFFFFF"/>
+                    </a:solidFill>
+                  </a:tcPr>
+                </a:tc>
+                <a:tc>
+                  <a:txBody>
+                    <a:bodyPr/>
+                    <a:lstStyle/>
+                    <a:p>
+                      <a:pPr algn="ctr">
+                        <a:buNone/>
+                      </a:pPr>
+                      <a:r>
+                        <a:rPr lang="en-GB" sz="1500" b="0" dirty="0">
+                          <a:solidFill>
+                            <a:srgbClr val="991B1B"/>
+                          </a:solidFill>
+                          <a:latin typeface="+mn-lt"/>
+                        </a:rPr>
+                        <a:t>−0.85</a:t>
+                      </a:r>
+                    </a:p>
+                  </a:txBody>
+                  <a:tcPr marL="64008" marR="64008" marT="27432" marB="27432" anchor="ctr">
+                    <a:lnL w="9525">
+                      <a:solidFill>
+                        <a:srgbClr val="CBD5E1"/>
+                      </a:solidFill>
+                    </a:lnL>
+                    <a:lnR w="9525">
+                      <a:solidFill>
+                        <a:srgbClr val="CBD5E1"/>
+                      </a:solidFill>
+                    </a:lnR>
+                    <a:lnT w="9525">
+                      <a:solidFill>
+                        <a:srgbClr val="CBD5E1"/>
+                      </a:solidFill>
+                    </a:lnT>
+                    <a:lnB w="9525">
+                      <a:solidFill>
+                        <a:srgbClr val="CBD5E1"/>
+                      </a:solidFill>
+                    </a:lnB>
+                    <a:solidFill>
+                      <a:srgbClr val="FDE2E2"/>
+                    </a:solidFill>
+                  </a:tcPr>
+                </a:tc>
+                <a:tc>
+                  <a:txBody>
+                    <a:bodyPr/>
+                    <a:lstStyle/>
+                    <a:p>
+                      <a:pPr algn="ctr">
+                        <a:buNone/>
+                      </a:pPr>
+                      <a:r>
+                        <a:rPr lang="en-GB" sz="1500" b="0" dirty="0">
+                          <a:solidFill>
+                            <a:srgbClr val="1E3A8A"/>
+                          </a:solidFill>
+                          <a:latin typeface="+mn-lt"/>
+                        </a:rPr>
+                        <a:t>+0.55</a:t>
+                      </a:r>
+                    </a:p>
+                  </a:txBody>
+                  <a:tcPr marL="64008" marR="64008" marT="27432" marB="27432" anchor="ctr">
+                    <a:lnL w="9525">
+                      <a:solidFill>
+                        <a:srgbClr val="CBD5E1"/>
+                      </a:solidFill>
+                    </a:lnL>
+                    <a:lnR w="9525">
+                      <a:solidFill>
+                        <a:srgbClr val="CBD5E1"/>
+                      </a:solidFill>
+                    </a:lnR>
+                    <a:lnT w="9525">
+                      <a:solidFill>
+                        <a:srgbClr val="CBD5E1"/>
+                      </a:solidFill>
+                    </a:lnT>
+                    <a:lnB w="9525">
+                      <a:solidFill>
+                        <a:srgbClr val="CBD5E1"/>
+                      </a:solidFill>
+                    </a:lnB>
+                    <a:solidFill>
+                      <a:srgbClr val="DBEAFE"/>
+                    </a:solidFill>
+                  </a:tcPr>
+                </a:tc>
+                <a:tc>
+                  <a:txBody>
+                    <a:bodyPr/>
+                    <a:lstStyle/>
+                    <a:p>
+                      <a:pPr algn="ctr">
+                        <a:buNone/>
+                      </a:pPr>
+                      <a:r>
+                        <a:rPr lang="en-GB" sz="1500" b="0" dirty="0">
+                          <a:solidFill>
+                            <a:srgbClr val="991B1B"/>
+                          </a:solidFill>
+                          <a:latin typeface="+mn-lt"/>
+                        </a:rPr>
+                        <a:t>−0.87</a:t>
+                      </a:r>
+                    </a:p>
+                  </a:txBody>
+                  <a:tcPr marL="64008" marR="64008" marT="27432" marB="27432" anchor="ctr">
+                    <a:lnL w="9525">
+                      <a:solidFill>
+                        <a:srgbClr val="CBD5E1"/>
+                      </a:solidFill>
+                    </a:lnL>
+                    <a:lnR w="9525">
+                      <a:solidFill>
+                        <a:srgbClr val="CBD5E1"/>
+                      </a:solidFill>
+                    </a:lnR>
+                    <a:lnT w="9525">
+                      <a:solidFill>
+                        <a:srgbClr val="CBD5E1"/>
+                      </a:solidFill>
+                    </a:lnT>
+                    <a:lnB w="9525">
+                      <a:solidFill>
+                        <a:srgbClr val="CBD5E1"/>
+                      </a:solidFill>
+                    </a:lnB>
+                    <a:solidFill>
+                      <a:srgbClr val="FDE2E2"/>
+                    </a:solidFill>
+                  </a:tcPr>
+                </a:tc>
+                <a:tc>
+                  <a:txBody>
+                    <a:bodyPr/>
+                    <a:lstStyle/>
+                    <a:p>
+                      <a:pPr algn="ctr">
+                        <a:buNone/>
+                      </a:pPr>
+                      <a:r>
+                        <a:rPr lang="en-GB" sz="1500" b="0" dirty="0">
+                          <a:solidFill>
+                            <a:srgbClr val="1E3A8A"/>
+                          </a:solidFill>
+                          <a:latin typeface="+mn-lt"/>
+                        </a:rPr>
+                        <a:t>+0.75</a:t>
+                      </a:r>
+                    </a:p>
+                  </a:txBody>
+                  <a:tcPr marL="64008" marR="64008" marT="27432" marB="27432" anchor="ctr">
+                    <a:lnL w="9525">
+                      <a:solidFill>
+                        <a:srgbClr val="CBD5E1"/>
+                      </a:solidFill>
+                    </a:lnL>
+                    <a:lnR w="9525">
+                      <a:solidFill>
+                        <a:srgbClr val="CBD5E1"/>
+                      </a:solidFill>
+                    </a:lnR>
+                    <a:lnT w="9525">
+                      <a:solidFill>
+                        <a:srgbClr val="CBD5E1"/>
+                      </a:solidFill>
+                    </a:lnT>
+                    <a:lnB w="9525">
+                      <a:solidFill>
+                        <a:srgbClr val="CBD5E1"/>
+                      </a:solidFill>
+                    </a:lnB>
+                    <a:solidFill>
+                      <a:srgbClr val="DBEAFE"/>
+                    </a:solidFill>
+                  </a:tcPr>
+                </a:tc>
+              </a:tr>
+            </a:tbl>
+          </a:graphicData>
+        </a:graphic>
+      </p:graphicFrame>
+      <p:sp>
+        <p:nvSpPr>
+          <p:cNvPr id="116" name="Sensitivity points"/>
+          <p:cNvSpPr txBox="1"/>
+          <p:nvPr/>
+        </p:nvSpPr>
+        <p:spPr>
+          <a:xfrm>
+            <a:off x="6446520" y="4480000"/>
+            <a:ext cx="4754880" cy="1560000"/>
+          </a:xfrm>
+          <a:prstGeom prst="rect">
+            <a:avLst/>
+          </a:prstGeom>
+          <a:noFill/>
+        </p:spPr>
+        <p:txBody>
+          <a:bodyPr wrap="square" lIns="0" tIns="0" rIns="0" bIns="0" anchor="t">
+            <a:noAutofit/>
+          </a:bodyPr>
+          <a:lstStyle/>
+          <a:p>
+            <a:pPr algn="l" marL="228600" indent="-228600">
               <a:spcAft>
-                <a:spcPts val="400"/>
+                <a:spcPts val="900"/>
               </a:spcAft>
-              <a:defRPr sz="1100">
+              <a:buClr>
+                <a:srgbClr val="1A56A0"/>
+              </a:buClr>
+              <a:buFont typeface="Arial"/>
+              <a:buChar char="•"/>
+            </a:pPr>
+            <a:r>
+              <a:rPr lang="en-GB" sz="1500" b="0" dirty="0">
                 <a:solidFill>
                   <a:srgbClr val="1E293B"/>
                 </a:solidFill>
-              </a:defRPr>
-            </a:pPr>
-            <a:r>
-              <a:t>- Local indices of R0: β +1, γ −0.59, μ −0.41, σ 0. A 10% cut in transmission lowers R0 by 10%.</a:t>
-            </a:r>
-          </a:p>
-          <a:p>
-            <a:pPr>
+                <a:latin typeface="+mn-lt"/>
+              </a:rPr>
+              <a:t>β raises everything; γ and μ shrink the epidemic, but μ raises total deaths.</a:t>
+            </a:r>
+          </a:p>
+          <a:p>
+            <a:pPr algn="l" marL="228600" indent="-228600">
               <a:spcAft>
-                <a:spcPts val="400"/>
+                <a:spcPts val="900"/>
               </a:spcAft>
-              <a:defRPr sz="1100">
+              <a:buClr>
+                <a:srgbClr val="1A56A0"/>
+              </a:buClr>
+              <a:buFont typeface="Arial"/>
+              <a:buChar char="•"/>
+            </a:pPr>
+            <a:r>
+              <a:rPr lang="en-GB" sz="1500" b="0" dirty="0">
                 <a:solidFill>
                   <a:srgbClr val="1E293B"/>
                 </a:solidFill>
-              </a:defRPr>
-            </a:pPr>
-            <a:r>
-              <a:t>- β pushes every output up (PRCC +0.90 to +0.98). γ and μ shrink the epidemic, but μ still raises total deaths (+0.75).</a:t>
-            </a:r>
-          </a:p>
-          <a:p>
-            <a:pPr>
-              <a:spcAft>
-                <a:spcPts val="400"/>
-              </a:spcAft>
-              <a:defRPr sz="1100">
+                <a:latin typeface="+mn-lt"/>
+              </a:rPr>
+              <a:t>σ moves the peak but not the final size (PRCC ≈ 0), as the formula predicts.</a:t>
+            </a:r>
+          </a:p>
+          <a:p>
+            <a:pPr algn="l" marL="228600" indent="-228600">
+              <a:buClr>
+                <a:srgbClr val="1A56A0"/>
+              </a:buClr>
+              <a:buFont typeface="Arial"/>
+              <a:buChar char="•"/>
+            </a:pPr>
+            <a:r>
+              <a:rPr lang="en-GB" sz="1500" b="0" dirty="0">
                 <a:solidFill>
                   <a:srgbClr val="1E293B"/>
                 </a:solidFill>
-              </a:defRPr>
-            </a:pPr>
-            <a:r>
-              <a:t>- σ moves the peak (height +0.68, timing −0.83) but not the final size (PRCC ≈ 0), as the formula predicts.</a:t>
-            </a:r>
-          </a:p>
-          <a:p>
-            <a:pPr>
-              <a:spcAft>
-                <a:spcPts val="400"/>
-              </a:spcAft>
-              <a:defRPr sz="1100">
-                <a:solidFill>
-                  <a:srgbClr val="1E293B"/>
-                </a:solidFill>
-              </a:defRPr>
-            </a:pPr>
-            <a:r>
-              <a:t>- With β(t) changing in time there is no closed formula, and cases plus deaths cannot separate σ, γ, μ. So we fix σ, γ and let the PINN learn β(t).</a:t>
+                <a:latin typeface="+mn-lt"/>
+              </a:rPr>
+              <a:t>Cases and deaths cannot separate σ, γ, μ: we fix σ, γ and the PINN learns β(t).</a:t>
             </a:r>
           </a:p>
         </p:txBody>

</xml_diff>

<commit_message>
Module 2: correct the day-250 error on slide 5 (3.6%, not 0.6%)
0.6% was the largest error among the table rows; the figure's finer
R0 grid peaks at 3.6% near R0 = 1.25, which is what the report says.

Co-Authored-By: Claude Opus 5.5 <noreply@anthropic.com>
</commit_message>
<xml_diff>
--- a/presentation/presentation_slides.pptx
+++ b/presentation/presentation_slides.pptx
@@ -6980,25 +6980,7 @@
                 </a:solidFill>
                 <a:latin typeface="+mn-lt"/>
               </a:rPr>
-              <a:t>The ODE must run until the epidemic ends (e + i &lt; 10</a:t>
-            </a:r>
-            <a:r>
-              <a:rPr lang="en-GB" sz="1600" b="0" baseline="30000" dirty="0">
-                <a:solidFill>
-                  <a:srgbClr val="1E293B"/>
-                </a:solidFill>
-                <a:latin typeface="+mn-lt"/>
-              </a:rPr>
-              <a:t>−13</a:t>
-            </a:r>
-            <a:r>
-              <a:rPr lang="en-GB" sz="1600" b="0" dirty="0">
-                <a:solidFill>
-                  <a:srgbClr val="1E293B"/>
-                </a:solidFill>
-                <a:latin typeface="+mn-lt"/>
-              </a:rPr>
-              <a:t>); stopping at day 250 gave errors up to 0.6%.</a:t>
+              <a:t>Run the ODE until the epidemic ends. Stopping at day 250 gave errors up to 3.6%.</a:t>
             </a:r>
           </a:p>
         </p:txBody>

</xml_diff>